<commit_message>
feat: implement K-Means unsupervised clustering evaluation script and update academic documentation with CO/PO mappings
</commit_message>
<xml_diff>
--- a/DigitVision_AI_Presentation.pptx
+++ b/DigitVision_AI_Presentation.pptx
@@ -25,6 +25,8 @@
     <p:sldId id="273" r:id="rId25"/>
     <p:sldId id="274" r:id="rId26"/>
     <p:sldId id="275" r:id="rId27"/>
+    <p:sldId id="276" r:id="rId28"/>
+    <p:sldId id="277" r:id="rId29"/>
   </p:sldIdLst>
   <p:sldSz cx="12191695" cy="6858000" type="screen4x3"/>
   <p:notesSz cx="6858000" cy="9144000"/>
@@ -1999,6 +2001,244 @@
           <a:p>
             <a:r>
               <a:t>A: My top priority would be deploying the model to on-device WebAssembly via ONNX Runtime to eliminate server latency, followed by implementing Monte Carlo Dropout to explicitly disentangle data noise (aleatoric uncertainty) from model parameter ignorance (epistemic uncertainty).</a:t>
+            </a:r>
+          </a:p>
+        </p:txBody>
+      </p:sp>
+      <p:sp>
+        <p:nvSpPr>
+          <p:cNvPr id="4" name="Slide Number Placeholder 3"/>
+          <p:cNvSpPr>
+            <a:spLocks noGrp="1"/>
+          </p:cNvSpPr>
+          <p:nvPr>
+            <p:ph type="sldNum" idx="5" sz="quarter"/>
+          </p:nvPr>
+        </p:nvSpPr>
+        <p:spPr/>
+      </p:sp>
+    </p:spTree>
+  </p:cSld>
+  <p:clrMapOvr>
+    <a:masterClrMapping/>
+  </p:clrMapOvr>
+</p:notes>
+</file>
+
+<file path=ppt/notesSlides/notesSlide21.xml><?xml version="1.0" encoding="utf-8"?>
+<p:notes xmlns:a="http://schemas.openxmlformats.org/drawingml/2006/main" xmlns:p="http://schemas.openxmlformats.org/presentationml/2006/main" xmlns:r="http://schemas.openxmlformats.org/officeDocument/2006/relationships">
+  <p:cSld>
+    <p:spTree>
+      <p:nvGrpSpPr>
+        <p:cNvPr id="1" name=""/>
+        <p:cNvGrpSpPr/>
+        <p:nvPr/>
+      </p:nvGrpSpPr>
+      <p:grpSpPr>
+        <a:xfrm>
+          <a:off x="0" y="0"/>
+          <a:ext cx="0" cy="0"/>
+          <a:chOff x="0" y="0"/>
+          <a:chExt cx="0" cy="0"/>
+        </a:xfrm>
+      </p:grpSpPr>
+      <p:sp>
+        <p:nvSpPr>
+          <p:cNvPr id="2" name="Slide Image Placeholder 1"/>
+          <p:cNvSpPr>
+            <a:spLocks noGrp="1"/>
+          </p:cNvSpPr>
+          <p:nvPr>
+            <p:ph type="sldImg" idx="2"/>
+          </p:nvPr>
+        </p:nvSpPr>
+        <p:spPr/>
+      </p:sp>
+      <p:sp>
+        <p:nvSpPr>
+          <p:cNvPr id="3" name="Notes Placeholder 2"/>
+          <p:cNvSpPr>
+            <a:spLocks noGrp="1"/>
+          </p:cNvSpPr>
+          <p:nvPr>
+            <p:ph type="body" idx="3" sz="quarter"/>
+          </p:nvPr>
+        </p:nvSpPr>
+        <p:spPr/>
+        <p:txBody>
+          <a:bodyPr/>
+          <a:lstStyle/>
+          <a:p>
+            <a:r>
+              <a:t>1. WHAT THE SLIDE COMMUNICATES:</a:t>
+            </a:r>
+          </a:p>
+          <a:p>
+            <a:r>
+              <a:t>Explicit audit of DigitVision AI codebase and experiments against official Machine Learning Lab Course Outcomes (CO1–CO6).</a:t>
+            </a:r>
+          </a:p>
+          <a:p/>
+          <a:p>
+            <a:r>
+              <a:t>2. WHY IT MATTERS:</a:t>
+            </a:r>
+          </a:p>
+          <a:p>
+            <a:r>
+              <a:t>Grounds the micro-project strictly in the academic curriculum requirements and proves genuine empirical completion without fabrication.</a:t>
+            </a:r>
+          </a:p>
+          <a:p/>
+          <a:p>
+            <a:r>
+              <a:t>3. TECHNICAL EXPLANATION:</a:t>
+            </a:r>
+          </a:p>
+          <a:p>
+            <a:r>
+              <a:t>CO1 and CO2 are grounded in statistical tensors and visual EDA; CO3 implements classical baselines; CO4 achieves temperature calibration (ECE 0.0031); CO5 executes K-Means clustering on 10,000 samples (58.87% purity); CO6 delivers the 7-model comparative capstone.</a:t>
+            </a:r>
+          </a:p>
+          <a:p/>
+          <a:p>
+            <a:r>
+              <a:t>4. LIKELY VIVA QUESTION:</a:t>
+            </a:r>
+          </a:p>
+          <a:p>
+            <a:r>
+              <a:t>Q: Why is CO3 marked as substantially demonstrated rather than 100% complete across all textbook algorithms?</a:t>
+            </a:r>
+          </a:p>
+          <a:p/>
+          <a:p>
+            <a:r>
+              <a:t>5. STRONG ANSWER:</a:t>
+            </a:r>
+          </a:p>
+          <a:p>
+            <a:r>
+              <a:t>A: We uphold academic rigor: Linear regression is inappropriate for a discrete 10-class problem, and KNN violates our &lt;10 ms latency requirement. We implemented Logistic Regression and Random Forest to establish rigorous baselines without fabricating unsuited models.</a:t>
+            </a:r>
+          </a:p>
+        </p:txBody>
+      </p:sp>
+      <p:sp>
+        <p:nvSpPr>
+          <p:cNvPr id="4" name="Slide Number Placeholder 3"/>
+          <p:cNvSpPr>
+            <a:spLocks noGrp="1"/>
+          </p:cNvSpPr>
+          <p:nvPr>
+            <p:ph type="sldNum" idx="5" sz="quarter"/>
+          </p:nvPr>
+        </p:nvSpPr>
+        <p:spPr/>
+      </p:sp>
+    </p:spTree>
+  </p:cSld>
+  <p:clrMapOvr>
+    <a:masterClrMapping/>
+  </p:clrMapOvr>
+</p:notes>
+</file>
+
+<file path=ppt/notesSlides/notesSlide22.xml><?xml version="1.0" encoding="utf-8"?>
+<p:notes xmlns:a="http://schemas.openxmlformats.org/drawingml/2006/main" xmlns:p="http://schemas.openxmlformats.org/presentationml/2006/main" xmlns:r="http://schemas.openxmlformats.org/officeDocument/2006/relationships">
+  <p:cSld>
+    <p:spTree>
+      <p:nvGrpSpPr>
+        <p:cNvPr id="1" name=""/>
+        <p:cNvGrpSpPr/>
+        <p:nvPr/>
+      </p:nvGrpSpPr>
+      <p:grpSpPr>
+        <a:xfrm>
+          <a:off x="0" y="0"/>
+          <a:ext cx="0" cy="0"/>
+          <a:chOff x="0" y="0"/>
+          <a:chExt cx="0" cy="0"/>
+        </a:xfrm>
+      </p:grpSpPr>
+      <p:sp>
+        <p:nvSpPr>
+          <p:cNvPr id="2" name="Slide Image Placeholder 1"/>
+          <p:cNvSpPr>
+            <a:spLocks noGrp="1"/>
+          </p:cNvSpPr>
+          <p:nvPr>
+            <p:ph type="sldImg" idx="2"/>
+          </p:nvPr>
+        </p:nvSpPr>
+        <p:spPr/>
+      </p:sp>
+      <p:sp>
+        <p:nvSpPr>
+          <p:cNvPr id="3" name="Notes Placeholder 2"/>
+          <p:cNvSpPr>
+            <a:spLocks noGrp="1"/>
+          </p:cNvSpPr>
+          <p:nvPr>
+            <p:ph type="body" idx="3" sz="quarter"/>
+          </p:nvPr>
+        </p:nvSpPr>
+        <p:spPr/>
+        <p:txBody>
+          <a:bodyPr/>
+          <a:lstStyle/>
+          <a:p>
+            <a:r>
+              <a:t>1. WHAT THE SLIDE COMMUNICATES:</a:t>
+            </a:r>
+          </a:p>
+          <a:p>
+            <a:r>
+              <a:t>Forensic NBA Tier-I CO-PO and PSO mapping matrix with average correlation scores and empirical justifications.</a:t>
+            </a:r>
+          </a:p>
+          <a:p/>
+          <a:p>
+            <a:r>
+              <a:t>2. WHY IT MATTERS:</a:t>
+            </a:r>
+          </a:p>
+          <a:p>
+            <a:r>
+              <a:t>Meets Washington Accord and NBA outcome-based education standards, demonstrating how each engineering graduate attribute was cultivated.</a:t>
+            </a:r>
+          </a:p>
+          <a:p/>
+          <a:p>
+            <a:r>
+              <a:t>3. TECHNICAL EXPLANATION:</a:t>
+            </a:r>
+          </a:p>
+          <a:p>
+            <a:r>
+              <a:t>Correlation values (3=High, 2=Moderate, 1=Low, —=None) are assigned strictly when supported by code, tests, or documentation. Zero correlation is preserved where evidence does not exist.</a:t>
+            </a:r>
+          </a:p>
+          <a:p/>
+          <a:p>
+            <a:r>
+              <a:t>4. LIKELY VIVA QUESTION:</a:t>
+            </a:r>
+          </a:p>
+          <a:p>
+            <a:r>
+              <a:t>Q: Why is PO7 (Ethics) mapped with moderate correlation (2) rather than a default 3?</a:t>
+            </a:r>
+          </a:p>
+          <a:p/>
+          <a:p>
+            <a:r>
+              <a:t>5. STRONG ANSWER:</a:t>
+            </a:r>
+          </a:p>
+          <a:p>
+            <a:r>
+              <a:t>A: We assigned a level 2 to reflect real, concrete ethical actions—specifically visual transparency via Grad-CAM and temperature calibration to prevent overconfident erroneous automation in high-stakes settings like banking—without exaggerating theoretical policy discussions.</a:t>
             </a:r>
           </a:p>
         </p:txBody>
@@ -5997,7 +6237,7 @@
               </a:defRPr>
             </a:pPr>
             <a:r>
-              <a:t>STUDENT TEAM: 22VE1A6701, 22VE1A6702, 22VE1A6703, 22VE1A6704  •  SREYAS INSTITUTE OF ENGINEERING &amp; TECHNOLOGY</a:t>
+              <a:t>STUDENT TEAM: 24VE1A6695 (M TEJAS YADAV), 24VE1A6692 (K Charan Teja), 24VE1A66C8 (Y Akshay Raj)  •  SREYAS INSTITUTE OF ENGINEERING &amp; TECHNOLOGY</a:t>
             </a:r>
           </a:p>
           <a:p>
@@ -11217,6 +11457,3400 @@
             </a:pPr>
             <a:r>
               <a:t>•  Continuous Active Learning: Implement automated human-in-the-loop review for high-entropy rejected samples.</a:t>
+            </a:r>
+          </a:p>
+        </p:txBody>
+      </p:sp>
+    </p:spTree>
+  </p:cSld>
+  <p:clrMapOvr>
+    <a:masterClrMapping/>
+  </p:clrMapOvr>
+</p:sld>
+</file>
+
+<file path=ppt/slides/slide21.xml><?xml version="1.0" encoding="utf-8"?>
+<p:sld xmlns:a="http://schemas.openxmlformats.org/drawingml/2006/main" xmlns:p="http://schemas.openxmlformats.org/presentationml/2006/main" xmlns:r="http://schemas.openxmlformats.org/officeDocument/2006/relationships">
+  <p:cSld>
+    <p:bg>
+      <p:bgPr>
+        <a:solidFill>
+          <a:srgbClr val="050505"/>
+        </a:solidFill>
+        <a:effectLst/>
+      </p:bgPr>
+    </p:bg>
+    <p:spTree>
+      <p:nvGrpSpPr>
+        <p:cNvPr id="1" name=""/>
+        <p:cNvGrpSpPr/>
+        <p:nvPr/>
+      </p:nvGrpSpPr>
+      <p:grpSpPr/>
+      <p:sp>
+        <p:nvSpPr>
+          <p:cNvPr id="2" name="TextBox 1"/>
+          <p:cNvSpPr txBox="1"/>
+          <p:nvPr/>
+        </p:nvSpPr>
+        <p:spPr>
+          <a:xfrm>
+            <a:off x="731520" y="365760"/>
+            <a:ext cx="10698480" cy="822960"/>
+          </a:xfrm>
+          <a:prstGeom prst="rect">
+            <a:avLst/>
+          </a:prstGeom>
+          <a:noFill/>
+        </p:spPr>
+        <p:txBody>
+          <a:bodyPr wrap="square" lIns="0" tIns="0" rIns="0" bIns="0">
+            <a:spAutoFit/>
+          </a:bodyPr>
+          <a:lstStyle/>
+          <a:p>
+            <a:pPr>
+              <a:defRPr sz="900" b="1">
+                <a:solidFill>
+                  <a:srgbClr val="1DB954"/>
+                </a:solidFill>
+                <a:latin typeface="Consolas"/>
+              </a:defRPr>
+            </a:pPr>
+            <a:r>
+              <a:t>21. ACADEMIC COURSE OUTCOMES (CO) AUDIT</a:t>
+            </a:r>
+          </a:p>
+          <a:p>
+            <a:pPr>
+              <a:defRPr sz="1800" b="1">
+                <a:solidFill>
+                  <a:srgbClr val="FFFFFF"/>
+                </a:solidFill>
+                <a:latin typeface="Segoe UI"/>
+              </a:defRPr>
+            </a:pPr>
+            <a:r>
+              <a:t>COURSE OUTCOMES (CO1–CO6) ALIGNMENT &amp; PROJECT EVIDENCE</a:t>
+            </a:r>
+          </a:p>
+        </p:txBody>
+      </p:sp>
+      <p:sp>
+        <p:nvSpPr>
+          <p:cNvPr id="3" name="Rectangle 2"/>
+          <p:cNvSpPr/>
+          <p:nvPr/>
+        </p:nvSpPr>
+        <p:spPr>
+          <a:xfrm>
+            <a:off x="731520" y="1371600"/>
+            <a:ext cx="5212080" cy="4846320"/>
+          </a:xfrm>
+          <a:prstGeom prst="rect">
+            <a:avLst/>
+          </a:prstGeom>
+          <a:solidFill>
+            <a:srgbClr val="121212"/>
+          </a:solidFill>
+          <a:ln w="12700">
+            <a:solidFill>
+              <a:srgbClr val="262626"/>
+            </a:solidFill>
+          </a:ln>
+        </p:spPr>
+        <p:style>
+          <a:lnRef idx="1">
+            <a:schemeClr val="accent1"/>
+          </a:lnRef>
+          <a:fillRef idx="3">
+            <a:schemeClr val="accent1"/>
+          </a:fillRef>
+          <a:effectRef idx="2">
+            <a:schemeClr val="accent1"/>
+          </a:effectRef>
+          <a:fontRef idx="minor">
+            <a:schemeClr val="lt1"/>
+          </a:fontRef>
+        </p:style>
+        <p:txBody>
+          <a:bodyPr rtlCol="0" anchor="ctr"/>
+          <a:lstStyle/>
+          <a:p>
+            <a:pPr algn="ctr"/>
+          </a:p>
+        </p:txBody>
+      </p:sp>
+      <p:sp>
+        <p:nvSpPr>
+          <p:cNvPr id="4" name="TextBox 3"/>
+          <p:cNvSpPr txBox="1"/>
+          <p:nvPr/>
+        </p:nvSpPr>
+        <p:spPr>
+          <a:xfrm>
+            <a:off x="914400" y="1508760"/>
+            <a:ext cx="4846320" cy="320040"/>
+          </a:xfrm>
+          <a:prstGeom prst="rect">
+            <a:avLst/>
+          </a:prstGeom>
+          <a:noFill/>
+        </p:spPr>
+        <p:txBody>
+          <a:bodyPr wrap="square" lIns="0" tIns="0" rIns="0" bIns="0">
+            <a:spAutoFit/>
+          </a:bodyPr>
+          <a:lstStyle/>
+          <a:p>
+            <a:pPr>
+              <a:defRPr sz="1000" b="1">
+                <a:solidFill>
+                  <a:srgbClr val="A1A1AA"/>
+                </a:solidFill>
+                <a:latin typeface="Consolas"/>
+              </a:defRPr>
+            </a:pPr>
+            <a:r>
+              <a:t>CO1, CO2, CO3 — FOUNDATIONS &amp; SUPERVISED LEARNING</a:t>
+            </a:r>
+          </a:p>
+        </p:txBody>
+      </p:sp>
+      <p:sp>
+        <p:nvSpPr>
+          <p:cNvPr id="5" name="TextBox 4"/>
+          <p:cNvSpPr txBox="1"/>
+          <p:nvPr/>
+        </p:nvSpPr>
+        <p:spPr>
+          <a:xfrm>
+            <a:off x="914400" y="1828800"/>
+            <a:ext cx="4846320" cy="4206240"/>
+          </a:xfrm>
+          <a:prstGeom prst="rect">
+            <a:avLst/>
+          </a:prstGeom>
+          <a:noFill/>
+        </p:spPr>
+        <p:txBody>
+          <a:bodyPr wrap="square">
+            <a:spAutoFit/>
+          </a:bodyPr>
+          <a:lstStyle/>
+          <a:p>
+            <a:pPr>
+              <a:defRPr sz="1000" b="1">
+                <a:solidFill>
+                  <a:srgbClr val="1DB954"/>
+                </a:solidFill>
+                <a:latin typeface="Consolas"/>
+              </a:defRPr>
+            </a:pPr>
+            <a:r>
+              <a:t>CO1 (L3) · CENTRAL TENDENCY &amp; DISPERSION</a:t>
+            </a:r>
+          </a:p>
+          <a:p>
+            <a:pPr>
+              <a:defRPr sz="850">
+                <a:solidFill>
+                  <a:srgbClr val="A1A1AA"/>
+                </a:solidFill>
+                <a:latin typeface="Segoe UI"/>
+              </a:defRPr>
+            </a:pPr>
+            <a:r>
+              <a:t>μ = 0.1307, σ = 0.3081 across 70,000 image tensors; per-class counts and background sparsity (&gt;80%).</a:t>
+            </a:r>
+            <a:br/>
+            <a:r>
+              <a:t>Evidence: src/data/dataset.py, src/data/eda.py</a:t>
+            </a:r>
+            <a:br/>
+            <a:r>
+              <a:t>Status: Fully Demonstrated [Pending Faculty CIE Assessment]</a:t>
+            </a:r>
+            <a:br/>
+          </a:p>
+          <a:p>
+            <a:pPr>
+              <a:defRPr sz="1000" b="1">
+                <a:solidFill>
+                  <a:srgbClr val="1DB954"/>
+                </a:solidFill>
+                <a:latin typeface="Consolas"/>
+              </a:defRPr>
+            </a:pPr>
+            <a:r>
+              <a:t>CO2 (L3) · SCIENTIFIC PYTHON &amp; EDA</a:t>
+            </a:r>
+          </a:p>
+          <a:p>
+            <a:pPr>
+              <a:defRPr sz="850">
+                <a:solidFill>
+                  <a:srgbClr val="A1A1AA"/>
+                </a:solidFill>
+                <a:latin typeface="Segoe UI"/>
+              </a:defRPr>
+            </a:pPr>
+            <a:r>
+              <a:t>NumPy 784-D arrays, SciPy spatial metrics, Pandas data dictionaries, Matplotlib &amp; Seaborn plots.</a:t>
+            </a:r>
+            <a:br/>
+            <a:r>
+              <a:t>Evidence: 5 publication EDA figures (10×10 grid, bimodal histograms, stroke spines).</a:t>
+            </a:r>
+            <a:br/>
+            <a:r>
+              <a:t>Status: Fully Demonstrated [Pending Faculty CIE Assessment]</a:t>
+            </a:r>
+            <a:br/>
+          </a:p>
+          <a:p>
+            <a:pPr>
+              <a:defRPr sz="1000" b="1">
+                <a:solidFill>
+                  <a:srgbClr val="FFB000"/>
+                </a:solidFill>
+                <a:latin typeface="Consolas"/>
+              </a:defRPr>
+            </a:pPr>
+            <a:r>
+              <a:t>CO3 (L4) · SUPERVISED LEARNING ALGORITHMS</a:t>
+            </a:r>
+          </a:p>
+          <a:p>
+            <a:pPr>
+              <a:defRPr sz="850">
+                <a:solidFill>
+                  <a:srgbClr val="A1A1AA"/>
+                </a:solidFill>
+                <a:latin typeface="Segoe UI"/>
+              </a:defRPr>
+            </a:pPr>
+            <a:r>
+              <a:t>L2 Multinomial Logistic Regression (91.49%) and Random Forest (95.48%) classical baselines.</a:t>
+            </a:r>
+            <a:br/>
+            <a:r>
+              <a:t>Rationale: Linear Reg &amp; KNN omitted (discrete 10-class task; latency &lt;10 ms requirement).</a:t>
+            </a:r>
+            <a:br/>
+            <a:r>
+              <a:t>Status: Substantially Demonstrated [Pending Faculty CIE Assessment]</a:t>
+            </a:r>
+            <a:br/>
+          </a:p>
+        </p:txBody>
+      </p:sp>
+      <p:sp>
+        <p:nvSpPr>
+          <p:cNvPr id="6" name="Rectangle 5"/>
+          <p:cNvSpPr/>
+          <p:nvPr/>
+        </p:nvSpPr>
+        <p:spPr>
+          <a:xfrm>
+            <a:off x="6217920" y="1371600"/>
+            <a:ext cx="5212080" cy="4846320"/>
+          </a:xfrm>
+          <a:prstGeom prst="rect">
+            <a:avLst/>
+          </a:prstGeom>
+          <a:solidFill>
+            <a:srgbClr val="121212"/>
+          </a:solidFill>
+          <a:ln w="12700">
+            <a:solidFill>
+              <a:srgbClr val="262626"/>
+            </a:solidFill>
+          </a:ln>
+        </p:spPr>
+        <p:style>
+          <a:lnRef idx="1">
+            <a:schemeClr val="accent1"/>
+          </a:lnRef>
+          <a:fillRef idx="3">
+            <a:schemeClr val="accent1"/>
+          </a:fillRef>
+          <a:effectRef idx="2">
+            <a:schemeClr val="accent1"/>
+          </a:effectRef>
+          <a:fontRef idx="minor">
+            <a:schemeClr val="lt1"/>
+          </a:fontRef>
+        </p:style>
+        <p:txBody>
+          <a:bodyPr rtlCol="0" anchor="ctr"/>
+          <a:lstStyle/>
+          <a:p>
+            <a:pPr algn="ctr"/>
+          </a:p>
+        </p:txBody>
+      </p:sp>
+      <p:sp>
+        <p:nvSpPr>
+          <p:cNvPr id="7" name="TextBox 6"/>
+          <p:cNvSpPr txBox="1"/>
+          <p:nvPr/>
+        </p:nvSpPr>
+        <p:spPr>
+          <a:xfrm>
+            <a:off x="6400800" y="1508760"/>
+            <a:ext cx="4846320" cy="320040"/>
+          </a:xfrm>
+          <a:prstGeom prst="rect">
+            <a:avLst/>
+          </a:prstGeom>
+          <a:noFill/>
+        </p:spPr>
+        <p:txBody>
+          <a:bodyPr wrap="square" lIns="0" tIns="0" rIns="0" bIns="0">
+            <a:spAutoFit/>
+          </a:bodyPr>
+          <a:lstStyle/>
+          <a:p>
+            <a:pPr>
+              <a:defRPr sz="1000" b="1">
+                <a:solidFill>
+                  <a:srgbClr val="A1A1AA"/>
+                </a:solidFill>
+                <a:latin typeface="Consolas"/>
+              </a:defRPr>
+            </a:pPr>
+            <a:r>
+              <a:t>CO4, CO5, CO6 — TUNING, UNSUPERVISED &amp; CAPSTONE</a:t>
+            </a:r>
+          </a:p>
+        </p:txBody>
+      </p:sp>
+      <p:sp>
+        <p:nvSpPr>
+          <p:cNvPr id="8" name="TextBox 7"/>
+          <p:cNvSpPr txBox="1"/>
+          <p:nvPr/>
+        </p:nvSpPr>
+        <p:spPr>
+          <a:xfrm>
+            <a:off x="6400800" y="1828800"/>
+            <a:ext cx="4846320" cy="4206240"/>
+          </a:xfrm>
+          <a:prstGeom prst="rect">
+            <a:avLst/>
+          </a:prstGeom>
+          <a:noFill/>
+        </p:spPr>
+        <p:txBody>
+          <a:bodyPr wrap="square">
+            <a:spAutoFit/>
+          </a:bodyPr>
+          <a:lstStyle/>
+          <a:p>
+            <a:pPr>
+              <a:defRPr sz="1000" b="1">
+                <a:solidFill>
+                  <a:srgbClr val="1DB954"/>
+                </a:solidFill>
+                <a:latin typeface="Consolas"/>
+              </a:defRPr>
+            </a:pPr>
+            <a:r>
+              <a:t>CO4 (L4) · PARAMETER TUNING &amp; EVALUATION</a:t>
+            </a:r>
+          </a:p>
+          <a:p>
+            <a:pPr>
+              <a:defRPr sz="850">
+                <a:solidFill>
+                  <a:srgbClr val="A1A1AA"/>
+                </a:solidFill>
+                <a:latin typeface="Segoe UI"/>
+              </a:defRPr>
+            </a:pPr>
+            <a:r>
+              <a:t>7 metrics (Acc, Prec, Rec, F1, Loss, ECE, Latency), scikit-learn classification reports, ROC/PR curves.</a:t>
+            </a:r>
+            <a:br/>
+            <a:r>
+              <a:t>Temperature scaling (T = 0.9170, ECE reduced to 0.0031).</a:t>
+            </a:r>
+            <a:br/>
+            <a:r>
+              <a:t>Evidence: src/evaluation/metrics.py, src/evaluation/calibration.py</a:t>
+            </a:r>
+            <a:br/>
+            <a:r>
+              <a:t>Status: Fully Demonstrated [Pending Faculty CIE Assessment]</a:t>
+            </a:r>
+            <a:br/>
+          </a:p>
+          <a:p>
+            <a:pPr>
+              <a:defRPr sz="1000" b="1">
+                <a:solidFill>
+                  <a:srgbClr val="1DB954"/>
+                </a:solidFill>
+                <a:latin typeface="Consolas"/>
+              </a:defRPr>
+            </a:pPr>
+            <a:r>
+              <a:t>CO5 (L4) · UNSUPERVISED CLUSTERING (K-MEANS)</a:t>
+            </a:r>
+          </a:p>
+          <a:p>
+            <a:pPr>
+              <a:defRPr sz="850">
+                <a:solidFill>
+                  <a:srgbClr val="A1A1AA"/>
+                </a:solidFill>
+                <a:latin typeface="Segoe UI"/>
+              </a:defRPr>
+            </a:pPr>
+            <a:r>
+              <a:t>K = 10 clustering on 10,000 samples (Inertia: 389,394.88, V-Measure: 0.5017, Purity: 58.87%).</a:t>
+            </a:r>
+            <a:br/>
+            <a:r>
+              <a:t>Centroids: Cluster 4 (digit 0: 92.71% purity), Cluster 3 (digit 6: 89.48%).</a:t>
+            </a:r>
+            <a:br/>
+            <a:r>
+              <a:t>Evidence: src/evaluation/clustering.py, Fig 3.3</a:t>
+            </a:r>
+            <a:br/>
+            <a:r>
+              <a:t>Status: Fully Demonstrated [Pending Faculty CIE Assessment]</a:t>
+            </a:r>
+            <a:br/>
+          </a:p>
+          <a:p>
+            <a:pPr>
+              <a:defRPr sz="1000" b="1">
+                <a:solidFill>
+                  <a:srgbClr val="1DB954"/>
+                </a:solidFill>
+                <a:latin typeface="Consolas"/>
+              </a:defRPr>
+            </a:pPr>
+            <a:r>
+              <a:t>CO6 (L5) · COMPARATIVE CLASSIFICATION CAPSTONE</a:t>
+            </a:r>
+          </a:p>
+          <a:p>
+            <a:pPr>
+              <a:defRPr sz="850">
+                <a:solidFill>
+                  <a:srgbClr val="A1A1AA"/>
+                </a:solidFill>
+                <a:latin typeface="Segoe UI"/>
+              </a:defRPr>
+            </a:pPr>
+            <a:r>
+              <a:t>7-model benchmark (Baseline to DeepConvNet at 98.31% acc); dual-block CNN with GAP &amp; Grad-CAM XAI.</a:t>
+            </a:r>
+            <a:br/>
+            <a:r>
+              <a:t>FastAPI async backend + HTML5 canvas HUD. 33/33 tests passing.</a:t>
+            </a:r>
+            <a:br/>
+            <a:r>
+              <a:t>Evidence: src/evaluation/benchmark.py, main.py</a:t>
+            </a:r>
+            <a:br/>
+            <a:r>
+              <a:t>Status: Fully Demonstrated [Pending Faculty CIE Assessment]</a:t>
+            </a:r>
+            <a:br/>
+          </a:p>
+        </p:txBody>
+      </p:sp>
+    </p:spTree>
+  </p:cSld>
+  <p:clrMapOvr>
+    <a:masterClrMapping/>
+  </p:clrMapOvr>
+</p:sld>
+</file>
+
+<file path=ppt/slides/slide22.xml><?xml version="1.0" encoding="utf-8"?>
+<p:sld xmlns:a="http://schemas.openxmlformats.org/drawingml/2006/main" xmlns:p="http://schemas.openxmlformats.org/presentationml/2006/main" xmlns:r="http://schemas.openxmlformats.org/officeDocument/2006/relationships">
+  <p:cSld>
+    <p:bg>
+      <p:bgPr>
+        <a:solidFill>
+          <a:srgbClr val="050505"/>
+        </a:solidFill>
+        <a:effectLst/>
+      </p:bgPr>
+    </p:bg>
+    <p:spTree>
+      <p:nvGrpSpPr>
+        <p:cNvPr id="1" name=""/>
+        <p:cNvGrpSpPr/>
+        <p:nvPr/>
+      </p:nvGrpSpPr>
+      <p:grpSpPr/>
+      <p:sp>
+        <p:nvSpPr>
+          <p:cNvPr id="2" name="TextBox 1"/>
+          <p:cNvSpPr txBox="1"/>
+          <p:nvPr/>
+        </p:nvSpPr>
+        <p:spPr>
+          <a:xfrm>
+            <a:off x="731520" y="365760"/>
+            <a:ext cx="10698480" cy="822960"/>
+          </a:xfrm>
+          <a:prstGeom prst="rect">
+            <a:avLst/>
+          </a:prstGeom>
+          <a:noFill/>
+        </p:spPr>
+        <p:txBody>
+          <a:bodyPr wrap="square" lIns="0" tIns="0" rIns="0" bIns="0">
+            <a:spAutoFit/>
+          </a:bodyPr>
+          <a:lstStyle/>
+          <a:p>
+            <a:pPr>
+              <a:defRPr sz="900" b="1">
+                <a:solidFill>
+                  <a:srgbClr val="1DB954"/>
+                </a:solidFill>
+                <a:latin typeface="Consolas"/>
+              </a:defRPr>
+            </a:pPr>
+            <a:r>
+              <a:t>22. NBA OUTCOME ALIGNMENT &amp; CORRELATION MATRIX</a:t>
+            </a:r>
+          </a:p>
+          <a:p>
+            <a:pPr>
+              <a:defRPr sz="1800" b="1">
+                <a:solidFill>
+                  <a:srgbClr val="FFFFFF"/>
+                </a:solidFill>
+                <a:latin typeface="Segoe UI"/>
+              </a:defRPr>
+            </a:pPr>
+            <a:r>
+              <a:t>NBA SAR TIER-I CO–PO MAPPING MATRIX &amp; EMPIRICAL JUSTIFICATION</a:t>
+            </a:r>
+          </a:p>
+        </p:txBody>
+      </p:sp>
+      <p:graphicFrame>
+        <p:nvGraphicFramePr>
+          <p:cNvPr id="3" name="Table 2"/>
+          <p:cNvGraphicFramePr>
+            <a:graphicFrameLocks noGrp="1"/>
+          </p:cNvGraphicFramePr>
+          <p:nvPr/>
+        </p:nvGraphicFramePr>
+        <p:xfrm>
+          <a:off x="731520" y="1280160"/>
+          <a:ext cx="10698480" cy="2468880"/>
+        </p:xfrm>
+        <a:graphic>
+          <a:graphicData uri="http://schemas.openxmlformats.org/drawingml/2006/table">
+            <a:tbl>
+              <a:tblPr firstRow="1" bandRow="1">
+                <a:tableStyleId>{5C22544A-7EE6-4342-B048-85BDC9FD1C3A}</a:tableStyleId>
+              </a:tblPr>
+              <a:tblGrid>
+                <a:gridCol w="764177"/>
+                <a:gridCol w="764177"/>
+                <a:gridCol w="764177"/>
+                <a:gridCol w="764177"/>
+                <a:gridCol w="764177"/>
+                <a:gridCol w="764177"/>
+                <a:gridCol w="764177"/>
+                <a:gridCol w="764177"/>
+                <a:gridCol w="764177"/>
+                <a:gridCol w="764177"/>
+                <a:gridCol w="764177"/>
+                <a:gridCol w="764177"/>
+                <a:gridCol w="764177"/>
+                <a:gridCol w="764179"/>
+              </a:tblGrid>
+              <a:tr h="308610">
+                <a:tc>
+                  <a:txBody>
+                    <a:bodyPr/>
+                    <a:lstStyle/>
+                    <a:p>
+                      <a:pPr algn="ctr"/>
+                      <a:r>
+                        <a:rPr sz="900" b="1">
+                          <a:solidFill>
+                            <a:srgbClr val="FFFFFF"/>
+                          </a:solidFill>
+                          <a:latin typeface="Segoe UI"/>
+                        </a:rPr>
+                        <a:t>CO</a:t>
+                      </a:r>
+                    </a:p>
+                  </a:txBody>
+                  <a:tcPr>
+                    <a:solidFill>
+                      <a:srgbClr val="181818"/>
+                    </a:solidFill>
+                  </a:tcPr>
+                </a:tc>
+                <a:tc>
+                  <a:txBody>
+                    <a:bodyPr/>
+                    <a:lstStyle/>
+                    <a:p>
+                      <a:pPr algn="ctr"/>
+                      <a:r>
+                        <a:rPr sz="900" b="1">
+                          <a:solidFill>
+                            <a:srgbClr val="FFFFFF"/>
+                          </a:solidFill>
+                          <a:latin typeface="Segoe UI"/>
+                        </a:rPr>
+                        <a:t>PO1</a:t>
+                      </a:r>
+                    </a:p>
+                  </a:txBody>
+                  <a:tcPr>
+                    <a:solidFill>
+                      <a:srgbClr val="181818"/>
+                    </a:solidFill>
+                  </a:tcPr>
+                </a:tc>
+                <a:tc>
+                  <a:txBody>
+                    <a:bodyPr/>
+                    <a:lstStyle/>
+                    <a:p>
+                      <a:pPr algn="ctr"/>
+                      <a:r>
+                        <a:rPr sz="900" b="1">
+                          <a:solidFill>
+                            <a:srgbClr val="FFFFFF"/>
+                          </a:solidFill>
+                          <a:latin typeface="Segoe UI"/>
+                        </a:rPr>
+                        <a:t>PO2</a:t>
+                      </a:r>
+                    </a:p>
+                  </a:txBody>
+                  <a:tcPr>
+                    <a:solidFill>
+                      <a:srgbClr val="181818"/>
+                    </a:solidFill>
+                  </a:tcPr>
+                </a:tc>
+                <a:tc>
+                  <a:txBody>
+                    <a:bodyPr/>
+                    <a:lstStyle/>
+                    <a:p>
+                      <a:pPr algn="ctr"/>
+                      <a:r>
+                        <a:rPr sz="900" b="1">
+                          <a:solidFill>
+                            <a:srgbClr val="FFFFFF"/>
+                          </a:solidFill>
+                          <a:latin typeface="Segoe UI"/>
+                        </a:rPr>
+                        <a:t>PO3</a:t>
+                      </a:r>
+                    </a:p>
+                  </a:txBody>
+                  <a:tcPr>
+                    <a:solidFill>
+                      <a:srgbClr val="181818"/>
+                    </a:solidFill>
+                  </a:tcPr>
+                </a:tc>
+                <a:tc>
+                  <a:txBody>
+                    <a:bodyPr/>
+                    <a:lstStyle/>
+                    <a:p>
+                      <a:pPr algn="ctr"/>
+                      <a:r>
+                        <a:rPr sz="900" b="1">
+                          <a:solidFill>
+                            <a:srgbClr val="FFFFFF"/>
+                          </a:solidFill>
+                          <a:latin typeface="Segoe UI"/>
+                        </a:rPr>
+                        <a:t>PO4</a:t>
+                      </a:r>
+                    </a:p>
+                  </a:txBody>
+                  <a:tcPr>
+                    <a:solidFill>
+                      <a:srgbClr val="181818"/>
+                    </a:solidFill>
+                  </a:tcPr>
+                </a:tc>
+                <a:tc>
+                  <a:txBody>
+                    <a:bodyPr/>
+                    <a:lstStyle/>
+                    <a:p>
+                      <a:pPr algn="ctr"/>
+                      <a:r>
+                        <a:rPr sz="900" b="1">
+                          <a:solidFill>
+                            <a:srgbClr val="FFFFFF"/>
+                          </a:solidFill>
+                          <a:latin typeface="Segoe UI"/>
+                        </a:rPr>
+                        <a:t>PO5</a:t>
+                      </a:r>
+                    </a:p>
+                  </a:txBody>
+                  <a:tcPr>
+                    <a:solidFill>
+                      <a:srgbClr val="181818"/>
+                    </a:solidFill>
+                  </a:tcPr>
+                </a:tc>
+                <a:tc>
+                  <a:txBody>
+                    <a:bodyPr/>
+                    <a:lstStyle/>
+                    <a:p>
+                      <a:pPr algn="ctr"/>
+                      <a:r>
+                        <a:rPr sz="900" b="1">
+                          <a:solidFill>
+                            <a:srgbClr val="FFFFFF"/>
+                          </a:solidFill>
+                          <a:latin typeface="Segoe UI"/>
+                        </a:rPr>
+                        <a:t>PO6</a:t>
+                      </a:r>
+                    </a:p>
+                  </a:txBody>
+                  <a:tcPr>
+                    <a:solidFill>
+                      <a:srgbClr val="181818"/>
+                    </a:solidFill>
+                  </a:tcPr>
+                </a:tc>
+                <a:tc>
+                  <a:txBody>
+                    <a:bodyPr/>
+                    <a:lstStyle/>
+                    <a:p>
+                      <a:pPr algn="ctr"/>
+                      <a:r>
+                        <a:rPr sz="900" b="1">
+                          <a:solidFill>
+                            <a:srgbClr val="FFFFFF"/>
+                          </a:solidFill>
+                          <a:latin typeface="Segoe UI"/>
+                        </a:rPr>
+                        <a:t>PO7</a:t>
+                      </a:r>
+                    </a:p>
+                  </a:txBody>
+                  <a:tcPr>
+                    <a:solidFill>
+                      <a:srgbClr val="181818"/>
+                    </a:solidFill>
+                  </a:tcPr>
+                </a:tc>
+                <a:tc>
+                  <a:txBody>
+                    <a:bodyPr/>
+                    <a:lstStyle/>
+                    <a:p>
+                      <a:pPr algn="ctr"/>
+                      <a:r>
+                        <a:rPr sz="900" b="1">
+                          <a:solidFill>
+                            <a:srgbClr val="FFFFFF"/>
+                          </a:solidFill>
+                          <a:latin typeface="Segoe UI"/>
+                        </a:rPr>
+                        <a:t>PO8</a:t>
+                      </a:r>
+                    </a:p>
+                  </a:txBody>
+                  <a:tcPr>
+                    <a:solidFill>
+                      <a:srgbClr val="181818"/>
+                    </a:solidFill>
+                  </a:tcPr>
+                </a:tc>
+                <a:tc>
+                  <a:txBody>
+                    <a:bodyPr/>
+                    <a:lstStyle/>
+                    <a:p>
+                      <a:pPr algn="ctr"/>
+                      <a:r>
+                        <a:rPr sz="900" b="1">
+                          <a:solidFill>
+                            <a:srgbClr val="FFFFFF"/>
+                          </a:solidFill>
+                          <a:latin typeface="Segoe UI"/>
+                        </a:rPr>
+                        <a:t>PO9</a:t>
+                      </a:r>
+                    </a:p>
+                  </a:txBody>
+                  <a:tcPr>
+                    <a:solidFill>
+                      <a:srgbClr val="181818"/>
+                    </a:solidFill>
+                  </a:tcPr>
+                </a:tc>
+                <a:tc>
+                  <a:txBody>
+                    <a:bodyPr/>
+                    <a:lstStyle/>
+                    <a:p>
+                      <a:pPr algn="ctr"/>
+                      <a:r>
+                        <a:rPr sz="900" b="1">
+                          <a:solidFill>
+                            <a:srgbClr val="FFFFFF"/>
+                          </a:solidFill>
+                          <a:latin typeface="Segoe UI"/>
+                        </a:rPr>
+                        <a:t>PO10</a:t>
+                      </a:r>
+                    </a:p>
+                  </a:txBody>
+                  <a:tcPr>
+                    <a:solidFill>
+                      <a:srgbClr val="181818"/>
+                    </a:solidFill>
+                  </a:tcPr>
+                </a:tc>
+                <a:tc>
+                  <a:txBody>
+                    <a:bodyPr/>
+                    <a:lstStyle/>
+                    <a:p>
+                      <a:pPr algn="ctr"/>
+                      <a:r>
+                        <a:rPr sz="900" b="1">
+                          <a:solidFill>
+                            <a:srgbClr val="FFFFFF"/>
+                          </a:solidFill>
+                          <a:latin typeface="Segoe UI"/>
+                        </a:rPr>
+                        <a:t>PO11</a:t>
+                      </a:r>
+                    </a:p>
+                  </a:txBody>
+                  <a:tcPr>
+                    <a:solidFill>
+                      <a:srgbClr val="181818"/>
+                    </a:solidFill>
+                  </a:tcPr>
+                </a:tc>
+                <a:tc>
+                  <a:txBody>
+                    <a:bodyPr/>
+                    <a:lstStyle/>
+                    <a:p>
+                      <a:pPr algn="ctr"/>
+                      <a:r>
+                        <a:rPr sz="900" b="1">
+                          <a:solidFill>
+                            <a:srgbClr val="FFFFFF"/>
+                          </a:solidFill>
+                          <a:latin typeface="Segoe UI"/>
+                        </a:rPr>
+                        <a:t>PSO1</a:t>
+                      </a:r>
+                    </a:p>
+                  </a:txBody>
+                  <a:tcPr>
+                    <a:solidFill>
+                      <a:srgbClr val="181818"/>
+                    </a:solidFill>
+                  </a:tcPr>
+                </a:tc>
+                <a:tc>
+                  <a:txBody>
+                    <a:bodyPr/>
+                    <a:lstStyle/>
+                    <a:p>
+                      <a:pPr algn="ctr"/>
+                      <a:r>
+                        <a:rPr sz="900" b="1">
+                          <a:solidFill>
+                            <a:srgbClr val="FFFFFF"/>
+                          </a:solidFill>
+                          <a:latin typeface="Segoe UI"/>
+                        </a:rPr>
+                        <a:t>PSO2</a:t>
+                      </a:r>
+                    </a:p>
+                  </a:txBody>
+                  <a:tcPr>
+                    <a:solidFill>
+                      <a:srgbClr val="181818"/>
+                    </a:solidFill>
+                  </a:tcPr>
+                </a:tc>
+              </a:tr>
+              <a:tr h="308610">
+                <a:tc>
+                  <a:txBody>
+                    <a:bodyPr/>
+                    <a:lstStyle/>
+                    <a:p>
+                      <a:pPr algn="ctr"/>
+                      <a:r>
+                        <a:rPr sz="950" b="0">
+                          <a:solidFill>
+                            <a:srgbClr val="FFFFFF"/>
+                          </a:solidFill>
+                          <a:latin typeface="Consolas"/>
+                        </a:rPr>
+                        <a:t>CO1</a:t>
+                      </a:r>
+                    </a:p>
+                  </a:txBody>
+                  <a:tcPr>
+                    <a:solidFill>
+                      <a:srgbClr val="0A0A0A"/>
+                    </a:solidFill>
+                  </a:tcPr>
+                </a:tc>
+                <a:tc>
+                  <a:txBody>
+                    <a:bodyPr/>
+                    <a:lstStyle/>
+                    <a:p>
+                      <a:pPr algn="ctr"/>
+                      <a:r>
+                        <a:rPr sz="950" b="0">
+                          <a:solidFill>
+                            <a:srgbClr val="1DB954"/>
+                          </a:solidFill>
+                          <a:latin typeface="Consolas"/>
+                        </a:rPr>
+                        <a:t>3</a:t>
+                      </a:r>
+                    </a:p>
+                  </a:txBody>
+                  <a:tcPr>
+                    <a:solidFill>
+                      <a:srgbClr val="0A0A0A"/>
+                    </a:solidFill>
+                  </a:tcPr>
+                </a:tc>
+                <a:tc>
+                  <a:txBody>
+                    <a:bodyPr/>
+                    <a:lstStyle/>
+                    <a:p>
+                      <a:pPr algn="ctr"/>
+                      <a:r>
+                        <a:rPr sz="950" b="0">
+                          <a:solidFill>
+                            <a:srgbClr val="FFB000"/>
+                          </a:solidFill>
+                          <a:latin typeface="Consolas"/>
+                        </a:rPr>
+                        <a:t>2</a:t>
+                      </a:r>
+                    </a:p>
+                  </a:txBody>
+                  <a:tcPr>
+                    <a:solidFill>
+                      <a:srgbClr val="0A0A0A"/>
+                    </a:solidFill>
+                  </a:tcPr>
+                </a:tc>
+                <a:tc>
+                  <a:txBody>
+                    <a:bodyPr/>
+                    <a:lstStyle/>
+                    <a:p>
+                      <a:pPr algn="ctr"/>
+                      <a:r>
+                        <a:rPr sz="950" b="0">
+                          <a:solidFill>
+                            <a:srgbClr val="737373"/>
+                          </a:solidFill>
+                          <a:latin typeface="Consolas"/>
+                        </a:rPr>
+                        <a:t>—</a:t>
+                      </a:r>
+                    </a:p>
+                  </a:txBody>
+                  <a:tcPr>
+                    <a:solidFill>
+                      <a:srgbClr val="0A0A0A"/>
+                    </a:solidFill>
+                  </a:tcPr>
+                </a:tc>
+                <a:tc>
+                  <a:txBody>
+                    <a:bodyPr/>
+                    <a:lstStyle/>
+                    <a:p>
+                      <a:pPr algn="ctr"/>
+                      <a:r>
+                        <a:rPr sz="950" b="0">
+                          <a:solidFill>
+                            <a:srgbClr val="FFB000"/>
+                          </a:solidFill>
+                          <a:latin typeface="Consolas"/>
+                        </a:rPr>
+                        <a:t>2</a:t>
+                      </a:r>
+                    </a:p>
+                  </a:txBody>
+                  <a:tcPr>
+                    <a:solidFill>
+                      <a:srgbClr val="0A0A0A"/>
+                    </a:solidFill>
+                  </a:tcPr>
+                </a:tc>
+                <a:tc>
+                  <a:txBody>
+                    <a:bodyPr/>
+                    <a:lstStyle/>
+                    <a:p>
+                      <a:pPr algn="ctr"/>
+                      <a:r>
+                        <a:rPr sz="950" b="0">
+                          <a:solidFill>
+                            <a:srgbClr val="1DB954"/>
+                          </a:solidFill>
+                          <a:latin typeface="Consolas"/>
+                        </a:rPr>
+                        <a:t>3</a:t>
+                      </a:r>
+                    </a:p>
+                  </a:txBody>
+                  <a:tcPr>
+                    <a:solidFill>
+                      <a:srgbClr val="0A0A0A"/>
+                    </a:solidFill>
+                  </a:tcPr>
+                </a:tc>
+                <a:tc>
+                  <a:txBody>
+                    <a:bodyPr/>
+                    <a:lstStyle/>
+                    <a:p>
+                      <a:pPr algn="ctr"/>
+                      <a:r>
+                        <a:rPr sz="950" b="0">
+                          <a:solidFill>
+                            <a:srgbClr val="737373"/>
+                          </a:solidFill>
+                          <a:latin typeface="Consolas"/>
+                        </a:rPr>
+                        <a:t>—</a:t>
+                      </a:r>
+                    </a:p>
+                  </a:txBody>
+                  <a:tcPr>
+                    <a:solidFill>
+                      <a:srgbClr val="0A0A0A"/>
+                    </a:solidFill>
+                  </a:tcPr>
+                </a:tc>
+                <a:tc>
+                  <a:txBody>
+                    <a:bodyPr/>
+                    <a:lstStyle/>
+                    <a:p>
+                      <a:pPr algn="ctr"/>
+                      <a:r>
+                        <a:rPr sz="950" b="0">
+                          <a:solidFill>
+                            <a:srgbClr val="737373"/>
+                          </a:solidFill>
+                          <a:latin typeface="Consolas"/>
+                        </a:rPr>
+                        <a:t>—</a:t>
+                      </a:r>
+                    </a:p>
+                  </a:txBody>
+                  <a:tcPr>
+                    <a:solidFill>
+                      <a:srgbClr val="0A0A0A"/>
+                    </a:solidFill>
+                  </a:tcPr>
+                </a:tc>
+                <a:tc>
+                  <a:txBody>
+                    <a:bodyPr/>
+                    <a:lstStyle/>
+                    <a:p>
+                      <a:pPr algn="ctr"/>
+                      <a:r>
+                        <a:rPr sz="950" b="0">
+                          <a:solidFill>
+                            <a:srgbClr val="737373"/>
+                          </a:solidFill>
+                          <a:latin typeface="Consolas"/>
+                        </a:rPr>
+                        <a:t>—</a:t>
+                      </a:r>
+                    </a:p>
+                  </a:txBody>
+                  <a:tcPr>
+                    <a:solidFill>
+                      <a:srgbClr val="0A0A0A"/>
+                    </a:solidFill>
+                  </a:tcPr>
+                </a:tc>
+                <a:tc>
+                  <a:txBody>
+                    <a:bodyPr/>
+                    <a:lstStyle/>
+                    <a:p>
+                      <a:pPr algn="ctr"/>
+                      <a:r>
+                        <a:rPr sz="950" b="0">
+                          <a:solidFill>
+                            <a:srgbClr val="737373"/>
+                          </a:solidFill>
+                          <a:latin typeface="Consolas"/>
+                        </a:rPr>
+                        <a:t>—</a:t>
+                      </a:r>
+                    </a:p>
+                  </a:txBody>
+                  <a:tcPr>
+                    <a:solidFill>
+                      <a:srgbClr val="0A0A0A"/>
+                    </a:solidFill>
+                  </a:tcPr>
+                </a:tc>
+                <a:tc>
+                  <a:txBody>
+                    <a:bodyPr/>
+                    <a:lstStyle/>
+                    <a:p>
+                      <a:pPr algn="ctr"/>
+                      <a:r>
+                        <a:rPr sz="950" b="0">
+                          <a:solidFill>
+                            <a:srgbClr val="737373"/>
+                          </a:solidFill>
+                          <a:latin typeface="Consolas"/>
+                        </a:rPr>
+                        <a:t>—</a:t>
+                      </a:r>
+                    </a:p>
+                  </a:txBody>
+                  <a:tcPr>
+                    <a:solidFill>
+                      <a:srgbClr val="0A0A0A"/>
+                    </a:solidFill>
+                  </a:tcPr>
+                </a:tc>
+                <a:tc>
+                  <a:txBody>
+                    <a:bodyPr/>
+                    <a:lstStyle/>
+                    <a:p>
+                      <a:pPr algn="ctr"/>
+                      <a:r>
+                        <a:rPr sz="950" b="0">
+                          <a:solidFill>
+                            <a:srgbClr val="737373"/>
+                          </a:solidFill>
+                          <a:latin typeface="Consolas"/>
+                        </a:rPr>
+                        <a:t>—</a:t>
+                      </a:r>
+                    </a:p>
+                  </a:txBody>
+                  <a:tcPr>
+                    <a:solidFill>
+                      <a:srgbClr val="0A0A0A"/>
+                    </a:solidFill>
+                  </a:tcPr>
+                </a:tc>
+                <a:tc>
+                  <a:txBody>
+                    <a:bodyPr/>
+                    <a:lstStyle/>
+                    <a:p>
+                      <a:pPr algn="ctr"/>
+                      <a:r>
+                        <a:rPr sz="950" b="0">
+                          <a:solidFill>
+                            <a:srgbClr val="1DB954"/>
+                          </a:solidFill>
+                          <a:latin typeface="Consolas"/>
+                        </a:rPr>
+                        <a:t>3</a:t>
+                      </a:r>
+                    </a:p>
+                  </a:txBody>
+                  <a:tcPr>
+                    <a:solidFill>
+                      <a:srgbClr val="0A0A0A"/>
+                    </a:solidFill>
+                  </a:tcPr>
+                </a:tc>
+                <a:tc>
+                  <a:txBody>
+                    <a:bodyPr/>
+                    <a:lstStyle/>
+                    <a:p>
+                      <a:pPr algn="ctr"/>
+                      <a:r>
+                        <a:rPr sz="950" b="0">
+                          <a:solidFill>
+                            <a:srgbClr val="FFB000"/>
+                          </a:solidFill>
+                          <a:latin typeface="Consolas"/>
+                        </a:rPr>
+                        <a:t>2</a:t>
+                      </a:r>
+                    </a:p>
+                  </a:txBody>
+                  <a:tcPr>
+                    <a:solidFill>
+                      <a:srgbClr val="0A0A0A"/>
+                    </a:solidFill>
+                  </a:tcPr>
+                </a:tc>
+              </a:tr>
+              <a:tr h="308610">
+                <a:tc>
+                  <a:txBody>
+                    <a:bodyPr/>
+                    <a:lstStyle/>
+                    <a:p>
+                      <a:pPr algn="ctr"/>
+                      <a:r>
+                        <a:rPr sz="950" b="0">
+                          <a:solidFill>
+                            <a:srgbClr val="FFFFFF"/>
+                          </a:solidFill>
+                          <a:latin typeface="Consolas"/>
+                        </a:rPr>
+                        <a:t>CO2</a:t>
+                      </a:r>
+                    </a:p>
+                  </a:txBody>
+                  <a:tcPr>
+                    <a:solidFill>
+                      <a:srgbClr val="0A0A0A"/>
+                    </a:solidFill>
+                  </a:tcPr>
+                </a:tc>
+                <a:tc>
+                  <a:txBody>
+                    <a:bodyPr/>
+                    <a:lstStyle/>
+                    <a:p>
+                      <a:pPr algn="ctr"/>
+                      <a:r>
+                        <a:rPr sz="950" b="0">
+                          <a:solidFill>
+                            <a:srgbClr val="1DB954"/>
+                          </a:solidFill>
+                          <a:latin typeface="Consolas"/>
+                        </a:rPr>
+                        <a:t>3</a:t>
+                      </a:r>
+                    </a:p>
+                  </a:txBody>
+                  <a:tcPr>
+                    <a:solidFill>
+                      <a:srgbClr val="0A0A0A"/>
+                    </a:solidFill>
+                  </a:tcPr>
+                </a:tc>
+                <a:tc>
+                  <a:txBody>
+                    <a:bodyPr/>
+                    <a:lstStyle/>
+                    <a:p>
+                      <a:pPr algn="ctr"/>
+                      <a:r>
+                        <a:rPr sz="950" b="0">
+                          <a:solidFill>
+                            <a:srgbClr val="1DB954"/>
+                          </a:solidFill>
+                          <a:latin typeface="Consolas"/>
+                        </a:rPr>
+                        <a:t>3</a:t>
+                      </a:r>
+                    </a:p>
+                  </a:txBody>
+                  <a:tcPr>
+                    <a:solidFill>
+                      <a:srgbClr val="0A0A0A"/>
+                    </a:solidFill>
+                  </a:tcPr>
+                </a:tc>
+                <a:tc>
+                  <a:txBody>
+                    <a:bodyPr/>
+                    <a:lstStyle/>
+                    <a:p>
+                      <a:pPr algn="ctr"/>
+                      <a:r>
+                        <a:rPr sz="950" b="0">
+                          <a:solidFill>
+                            <a:srgbClr val="737373"/>
+                          </a:solidFill>
+                          <a:latin typeface="Consolas"/>
+                        </a:rPr>
+                        <a:t>—</a:t>
+                      </a:r>
+                    </a:p>
+                  </a:txBody>
+                  <a:tcPr>
+                    <a:solidFill>
+                      <a:srgbClr val="0A0A0A"/>
+                    </a:solidFill>
+                  </a:tcPr>
+                </a:tc>
+                <a:tc>
+                  <a:txBody>
+                    <a:bodyPr/>
+                    <a:lstStyle/>
+                    <a:p>
+                      <a:pPr algn="ctr"/>
+                      <a:r>
+                        <a:rPr sz="950" b="0">
+                          <a:solidFill>
+                            <a:srgbClr val="1DB954"/>
+                          </a:solidFill>
+                          <a:latin typeface="Consolas"/>
+                        </a:rPr>
+                        <a:t>3</a:t>
+                      </a:r>
+                    </a:p>
+                  </a:txBody>
+                  <a:tcPr>
+                    <a:solidFill>
+                      <a:srgbClr val="0A0A0A"/>
+                    </a:solidFill>
+                  </a:tcPr>
+                </a:tc>
+                <a:tc>
+                  <a:txBody>
+                    <a:bodyPr/>
+                    <a:lstStyle/>
+                    <a:p>
+                      <a:pPr algn="ctr"/>
+                      <a:r>
+                        <a:rPr sz="950" b="0">
+                          <a:solidFill>
+                            <a:srgbClr val="1DB954"/>
+                          </a:solidFill>
+                          <a:latin typeface="Consolas"/>
+                        </a:rPr>
+                        <a:t>3</a:t>
+                      </a:r>
+                    </a:p>
+                  </a:txBody>
+                  <a:tcPr>
+                    <a:solidFill>
+                      <a:srgbClr val="0A0A0A"/>
+                    </a:solidFill>
+                  </a:tcPr>
+                </a:tc>
+                <a:tc>
+                  <a:txBody>
+                    <a:bodyPr/>
+                    <a:lstStyle/>
+                    <a:p>
+                      <a:pPr algn="ctr"/>
+                      <a:r>
+                        <a:rPr sz="950" b="0">
+                          <a:solidFill>
+                            <a:srgbClr val="737373"/>
+                          </a:solidFill>
+                          <a:latin typeface="Consolas"/>
+                        </a:rPr>
+                        <a:t>—</a:t>
+                      </a:r>
+                    </a:p>
+                  </a:txBody>
+                  <a:tcPr>
+                    <a:solidFill>
+                      <a:srgbClr val="0A0A0A"/>
+                    </a:solidFill>
+                  </a:tcPr>
+                </a:tc>
+                <a:tc>
+                  <a:txBody>
+                    <a:bodyPr/>
+                    <a:lstStyle/>
+                    <a:p>
+                      <a:pPr algn="ctr"/>
+                      <a:r>
+                        <a:rPr sz="950" b="0">
+                          <a:solidFill>
+                            <a:srgbClr val="737373"/>
+                          </a:solidFill>
+                          <a:latin typeface="Consolas"/>
+                        </a:rPr>
+                        <a:t>—</a:t>
+                      </a:r>
+                    </a:p>
+                  </a:txBody>
+                  <a:tcPr>
+                    <a:solidFill>
+                      <a:srgbClr val="0A0A0A"/>
+                    </a:solidFill>
+                  </a:tcPr>
+                </a:tc>
+                <a:tc>
+                  <a:txBody>
+                    <a:bodyPr/>
+                    <a:lstStyle/>
+                    <a:p>
+                      <a:pPr algn="ctr"/>
+                      <a:r>
+                        <a:rPr sz="950" b="0">
+                          <a:solidFill>
+                            <a:srgbClr val="737373"/>
+                          </a:solidFill>
+                          <a:latin typeface="Consolas"/>
+                        </a:rPr>
+                        <a:t>—</a:t>
+                      </a:r>
+                    </a:p>
+                  </a:txBody>
+                  <a:tcPr>
+                    <a:solidFill>
+                      <a:srgbClr val="0A0A0A"/>
+                    </a:solidFill>
+                  </a:tcPr>
+                </a:tc>
+                <a:tc>
+                  <a:txBody>
+                    <a:bodyPr/>
+                    <a:lstStyle/>
+                    <a:p>
+                      <a:pPr algn="ctr"/>
+                      <a:r>
+                        <a:rPr sz="950" b="0">
+                          <a:solidFill>
+                            <a:srgbClr val="FFB000"/>
+                          </a:solidFill>
+                          <a:latin typeface="Consolas"/>
+                        </a:rPr>
+                        <a:t>2</a:t>
+                      </a:r>
+                    </a:p>
+                  </a:txBody>
+                  <a:tcPr>
+                    <a:solidFill>
+                      <a:srgbClr val="0A0A0A"/>
+                    </a:solidFill>
+                  </a:tcPr>
+                </a:tc>
+                <a:tc>
+                  <a:txBody>
+                    <a:bodyPr/>
+                    <a:lstStyle/>
+                    <a:p>
+                      <a:pPr algn="ctr"/>
+                      <a:r>
+                        <a:rPr sz="950" b="0">
+                          <a:solidFill>
+                            <a:srgbClr val="737373"/>
+                          </a:solidFill>
+                          <a:latin typeface="Consolas"/>
+                        </a:rPr>
+                        <a:t>—</a:t>
+                      </a:r>
+                    </a:p>
+                  </a:txBody>
+                  <a:tcPr>
+                    <a:solidFill>
+                      <a:srgbClr val="0A0A0A"/>
+                    </a:solidFill>
+                  </a:tcPr>
+                </a:tc>
+                <a:tc>
+                  <a:txBody>
+                    <a:bodyPr/>
+                    <a:lstStyle/>
+                    <a:p>
+                      <a:pPr algn="ctr"/>
+                      <a:r>
+                        <a:rPr sz="950" b="0">
+                          <a:solidFill>
+                            <a:srgbClr val="737373"/>
+                          </a:solidFill>
+                          <a:latin typeface="Consolas"/>
+                        </a:rPr>
+                        <a:t>—</a:t>
+                      </a:r>
+                    </a:p>
+                  </a:txBody>
+                  <a:tcPr>
+                    <a:solidFill>
+                      <a:srgbClr val="0A0A0A"/>
+                    </a:solidFill>
+                  </a:tcPr>
+                </a:tc>
+                <a:tc>
+                  <a:txBody>
+                    <a:bodyPr/>
+                    <a:lstStyle/>
+                    <a:p>
+                      <a:pPr algn="ctr"/>
+                      <a:r>
+                        <a:rPr sz="950" b="0">
+                          <a:solidFill>
+                            <a:srgbClr val="1DB954"/>
+                          </a:solidFill>
+                          <a:latin typeface="Consolas"/>
+                        </a:rPr>
+                        <a:t>3</a:t>
+                      </a:r>
+                    </a:p>
+                  </a:txBody>
+                  <a:tcPr>
+                    <a:solidFill>
+                      <a:srgbClr val="0A0A0A"/>
+                    </a:solidFill>
+                  </a:tcPr>
+                </a:tc>
+                <a:tc>
+                  <a:txBody>
+                    <a:bodyPr/>
+                    <a:lstStyle/>
+                    <a:p>
+                      <a:pPr algn="ctr"/>
+                      <a:r>
+                        <a:rPr sz="950" b="0">
+                          <a:solidFill>
+                            <a:srgbClr val="1DB954"/>
+                          </a:solidFill>
+                          <a:latin typeface="Consolas"/>
+                        </a:rPr>
+                        <a:t>3</a:t>
+                      </a:r>
+                    </a:p>
+                  </a:txBody>
+                  <a:tcPr>
+                    <a:solidFill>
+                      <a:srgbClr val="0A0A0A"/>
+                    </a:solidFill>
+                  </a:tcPr>
+                </a:tc>
+              </a:tr>
+              <a:tr h="308610">
+                <a:tc>
+                  <a:txBody>
+                    <a:bodyPr/>
+                    <a:lstStyle/>
+                    <a:p>
+                      <a:pPr algn="ctr"/>
+                      <a:r>
+                        <a:rPr sz="950" b="0">
+                          <a:solidFill>
+                            <a:srgbClr val="FFFFFF"/>
+                          </a:solidFill>
+                          <a:latin typeface="Consolas"/>
+                        </a:rPr>
+                        <a:t>CO3</a:t>
+                      </a:r>
+                    </a:p>
+                  </a:txBody>
+                  <a:tcPr>
+                    <a:solidFill>
+                      <a:srgbClr val="0A0A0A"/>
+                    </a:solidFill>
+                  </a:tcPr>
+                </a:tc>
+                <a:tc>
+                  <a:txBody>
+                    <a:bodyPr/>
+                    <a:lstStyle/>
+                    <a:p>
+                      <a:pPr algn="ctr"/>
+                      <a:r>
+                        <a:rPr sz="950" b="0">
+                          <a:solidFill>
+                            <a:srgbClr val="1DB954"/>
+                          </a:solidFill>
+                          <a:latin typeface="Consolas"/>
+                        </a:rPr>
+                        <a:t>3</a:t>
+                      </a:r>
+                    </a:p>
+                  </a:txBody>
+                  <a:tcPr>
+                    <a:solidFill>
+                      <a:srgbClr val="0A0A0A"/>
+                    </a:solidFill>
+                  </a:tcPr>
+                </a:tc>
+                <a:tc>
+                  <a:txBody>
+                    <a:bodyPr/>
+                    <a:lstStyle/>
+                    <a:p>
+                      <a:pPr algn="ctr"/>
+                      <a:r>
+                        <a:rPr sz="950" b="0">
+                          <a:solidFill>
+                            <a:srgbClr val="1DB954"/>
+                          </a:solidFill>
+                          <a:latin typeface="Consolas"/>
+                        </a:rPr>
+                        <a:t>3</a:t>
+                      </a:r>
+                    </a:p>
+                  </a:txBody>
+                  <a:tcPr>
+                    <a:solidFill>
+                      <a:srgbClr val="0A0A0A"/>
+                    </a:solidFill>
+                  </a:tcPr>
+                </a:tc>
+                <a:tc>
+                  <a:txBody>
+                    <a:bodyPr/>
+                    <a:lstStyle/>
+                    <a:p>
+                      <a:pPr algn="ctr"/>
+                      <a:r>
+                        <a:rPr sz="950" b="0">
+                          <a:solidFill>
+                            <a:srgbClr val="1DB954"/>
+                          </a:solidFill>
+                          <a:latin typeface="Consolas"/>
+                        </a:rPr>
+                        <a:t>3</a:t>
+                      </a:r>
+                    </a:p>
+                  </a:txBody>
+                  <a:tcPr>
+                    <a:solidFill>
+                      <a:srgbClr val="0A0A0A"/>
+                    </a:solidFill>
+                  </a:tcPr>
+                </a:tc>
+                <a:tc>
+                  <a:txBody>
+                    <a:bodyPr/>
+                    <a:lstStyle/>
+                    <a:p>
+                      <a:pPr algn="ctr"/>
+                      <a:r>
+                        <a:rPr sz="950" b="0">
+                          <a:solidFill>
+                            <a:srgbClr val="FFB000"/>
+                          </a:solidFill>
+                          <a:latin typeface="Consolas"/>
+                        </a:rPr>
+                        <a:t>2</a:t>
+                      </a:r>
+                    </a:p>
+                  </a:txBody>
+                  <a:tcPr>
+                    <a:solidFill>
+                      <a:srgbClr val="0A0A0A"/>
+                    </a:solidFill>
+                  </a:tcPr>
+                </a:tc>
+                <a:tc>
+                  <a:txBody>
+                    <a:bodyPr/>
+                    <a:lstStyle/>
+                    <a:p>
+                      <a:pPr algn="ctr"/>
+                      <a:r>
+                        <a:rPr sz="950" b="0">
+                          <a:solidFill>
+                            <a:srgbClr val="1DB954"/>
+                          </a:solidFill>
+                          <a:latin typeface="Consolas"/>
+                        </a:rPr>
+                        <a:t>3</a:t>
+                      </a:r>
+                    </a:p>
+                  </a:txBody>
+                  <a:tcPr>
+                    <a:solidFill>
+                      <a:srgbClr val="0A0A0A"/>
+                    </a:solidFill>
+                  </a:tcPr>
+                </a:tc>
+                <a:tc>
+                  <a:txBody>
+                    <a:bodyPr/>
+                    <a:lstStyle/>
+                    <a:p>
+                      <a:pPr algn="ctr"/>
+                      <a:r>
+                        <a:rPr sz="950" b="0">
+                          <a:solidFill>
+                            <a:srgbClr val="737373"/>
+                          </a:solidFill>
+                          <a:latin typeface="Consolas"/>
+                        </a:rPr>
+                        <a:t>—</a:t>
+                      </a:r>
+                    </a:p>
+                  </a:txBody>
+                  <a:tcPr>
+                    <a:solidFill>
+                      <a:srgbClr val="0A0A0A"/>
+                    </a:solidFill>
+                  </a:tcPr>
+                </a:tc>
+                <a:tc>
+                  <a:txBody>
+                    <a:bodyPr/>
+                    <a:lstStyle/>
+                    <a:p>
+                      <a:pPr algn="ctr"/>
+                      <a:r>
+                        <a:rPr sz="950" b="0">
+                          <a:solidFill>
+                            <a:srgbClr val="737373"/>
+                          </a:solidFill>
+                          <a:latin typeface="Consolas"/>
+                        </a:rPr>
+                        <a:t>—</a:t>
+                      </a:r>
+                    </a:p>
+                  </a:txBody>
+                  <a:tcPr>
+                    <a:solidFill>
+                      <a:srgbClr val="0A0A0A"/>
+                    </a:solidFill>
+                  </a:tcPr>
+                </a:tc>
+                <a:tc>
+                  <a:txBody>
+                    <a:bodyPr/>
+                    <a:lstStyle/>
+                    <a:p>
+                      <a:pPr algn="ctr"/>
+                      <a:r>
+                        <a:rPr sz="950" b="0">
+                          <a:solidFill>
+                            <a:srgbClr val="FFB000"/>
+                          </a:solidFill>
+                          <a:latin typeface="Consolas"/>
+                        </a:rPr>
+                        <a:t>2</a:t>
+                      </a:r>
+                    </a:p>
+                  </a:txBody>
+                  <a:tcPr>
+                    <a:solidFill>
+                      <a:srgbClr val="0A0A0A"/>
+                    </a:solidFill>
+                  </a:tcPr>
+                </a:tc>
+                <a:tc>
+                  <a:txBody>
+                    <a:bodyPr/>
+                    <a:lstStyle/>
+                    <a:p>
+                      <a:pPr algn="ctr"/>
+                      <a:r>
+                        <a:rPr sz="950" b="0">
+                          <a:solidFill>
+                            <a:srgbClr val="737373"/>
+                          </a:solidFill>
+                          <a:latin typeface="Consolas"/>
+                        </a:rPr>
+                        <a:t>—</a:t>
+                      </a:r>
+                    </a:p>
+                  </a:txBody>
+                  <a:tcPr>
+                    <a:solidFill>
+                      <a:srgbClr val="0A0A0A"/>
+                    </a:solidFill>
+                  </a:tcPr>
+                </a:tc>
+                <a:tc>
+                  <a:txBody>
+                    <a:bodyPr/>
+                    <a:lstStyle/>
+                    <a:p>
+                      <a:pPr algn="ctr"/>
+                      <a:r>
+                        <a:rPr sz="950" b="0">
+                          <a:solidFill>
+                            <a:srgbClr val="737373"/>
+                          </a:solidFill>
+                          <a:latin typeface="Consolas"/>
+                        </a:rPr>
+                        <a:t>—</a:t>
+                      </a:r>
+                    </a:p>
+                  </a:txBody>
+                  <a:tcPr>
+                    <a:solidFill>
+                      <a:srgbClr val="0A0A0A"/>
+                    </a:solidFill>
+                  </a:tcPr>
+                </a:tc>
+                <a:tc>
+                  <a:txBody>
+                    <a:bodyPr/>
+                    <a:lstStyle/>
+                    <a:p>
+                      <a:pPr algn="ctr"/>
+                      <a:r>
+                        <a:rPr sz="950" b="0">
+                          <a:solidFill>
+                            <a:srgbClr val="737373"/>
+                          </a:solidFill>
+                          <a:latin typeface="Consolas"/>
+                        </a:rPr>
+                        <a:t>—</a:t>
+                      </a:r>
+                    </a:p>
+                  </a:txBody>
+                  <a:tcPr>
+                    <a:solidFill>
+                      <a:srgbClr val="0A0A0A"/>
+                    </a:solidFill>
+                  </a:tcPr>
+                </a:tc>
+                <a:tc>
+                  <a:txBody>
+                    <a:bodyPr/>
+                    <a:lstStyle/>
+                    <a:p>
+                      <a:pPr algn="ctr"/>
+                      <a:r>
+                        <a:rPr sz="950" b="0">
+                          <a:solidFill>
+                            <a:srgbClr val="1DB954"/>
+                          </a:solidFill>
+                          <a:latin typeface="Consolas"/>
+                        </a:rPr>
+                        <a:t>3</a:t>
+                      </a:r>
+                    </a:p>
+                  </a:txBody>
+                  <a:tcPr>
+                    <a:solidFill>
+                      <a:srgbClr val="0A0A0A"/>
+                    </a:solidFill>
+                  </a:tcPr>
+                </a:tc>
+                <a:tc>
+                  <a:txBody>
+                    <a:bodyPr/>
+                    <a:lstStyle/>
+                    <a:p>
+                      <a:pPr algn="ctr"/>
+                      <a:r>
+                        <a:rPr sz="950" b="0">
+                          <a:solidFill>
+                            <a:srgbClr val="1DB954"/>
+                          </a:solidFill>
+                          <a:latin typeface="Consolas"/>
+                        </a:rPr>
+                        <a:t>3</a:t>
+                      </a:r>
+                    </a:p>
+                  </a:txBody>
+                  <a:tcPr>
+                    <a:solidFill>
+                      <a:srgbClr val="0A0A0A"/>
+                    </a:solidFill>
+                  </a:tcPr>
+                </a:tc>
+              </a:tr>
+              <a:tr h="308610">
+                <a:tc>
+                  <a:txBody>
+                    <a:bodyPr/>
+                    <a:lstStyle/>
+                    <a:p>
+                      <a:pPr algn="ctr"/>
+                      <a:r>
+                        <a:rPr sz="950" b="0">
+                          <a:solidFill>
+                            <a:srgbClr val="FFFFFF"/>
+                          </a:solidFill>
+                          <a:latin typeface="Consolas"/>
+                        </a:rPr>
+                        <a:t>CO4</a:t>
+                      </a:r>
+                    </a:p>
+                  </a:txBody>
+                  <a:tcPr>
+                    <a:solidFill>
+                      <a:srgbClr val="0A0A0A"/>
+                    </a:solidFill>
+                  </a:tcPr>
+                </a:tc>
+                <a:tc>
+                  <a:txBody>
+                    <a:bodyPr/>
+                    <a:lstStyle/>
+                    <a:p>
+                      <a:pPr algn="ctr"/>
+                      <a:r>
+                        <a:rPr sz="950" b="0">
+                          <a:solidFill>
+                            <a:srgbClr val="1DB954"/>
+                          </a:solidFill>
+                          <a:latin typeface="Consolas"/>
+                        </a:rPr>
+                        <a:t>3</a:t>
+                      </a:r>
+                    </a:p>
+                  </a:txBody>
+                  <a:tcPr>
+                    <a:solidFill>
+                      <a:srgbClr val="0A0A0A"/>
+                    </a:solidFill>
+                  </a:tcPr>
+                </a:tc>
+                <a:tc>
+                  <a:txBody>
+                    <a:bodyPr/>
+                    <a:lstStyle/>
+                    <a:p>
+                      <a:pPr algn="ctr"/>
+                      <a:r>
+                        <a:rPr sz="950" b="0">
+                          <a:solidFill>
+                            <a:srgbClr val="1DB954"/>
+                          </a:solidFill>
+                          <a:latin typeface="Consolas"/>
+                        </a:rPr>
+                        <a:t>3</a:t>
+                      </a:r>
+                    </a:p>
+                  </a:txBody>
+                  <a:tcPr>
+                    <a:solidFill>
+                      <a:srgbClr val="0A0A0A"/>
+                    </a:solidFill>
+                  </a:tcPr>
+                </a:tc>
+                <a:tc>
+                  <a:txBody>
+                    <a:bodyPr/>
+                    <a:lstStyle/>
+                    <a:p>
+                      <a:pPr algn="ctr"/>
+                      <a:r>
+                        <a:rPr sz="950" b="0">
+                          <a:solidFill>
+                            <a:srgbClr val="737373"/>
+                          </a:solidFill>
+                          <a:latin typeface="Consolas"/>
+                        </a:rPr>
+                        <a:t>—</a:t>
+                      </a:r>
+                    </a:p>
+                  </a:txBody>
+                  <a:tcPr>
+                    <a:solidFill>
+                      <a:srgbClr val="0A0A0A"/>
+                    </a:solidFill>
+                  </a:tcPr>
+                </a:tc>
+                <a:tc>
+                  <a:txBody>
+                    <a:bodyPr/>
+                    <a:lstStyle/>
+                    <a:p>
+                      <a:pPr algn="ctr"/>
+                      <a:r>
+                        <a:rPr sz="950" b="0">
+                          <a:solidFill>
+                            <a:srgbClr val="1DB954"/>
+                          </a:solidFill>
+                          <a:latin typeface="Consolas"/>
+                        </a:rPr>
+                        <a:t>3</a:t>
+                      </a:r>
+                    </a:p>
+                  </a:txBody>
+                  <a:tcPr>
+                    <a:solidFill>
+                      <a:srgbClr val="0A0A0A"/>
+                    </a:solidFill>
+                  </a:tcPr>
+                </a:tc>
+                <a:tc>
+                  <a:txBody>
+                    <a:bodyPr/>
+                    <a:lstStyle/>
+                    <a:p>
+                      <a:pPr algn="ctr"/>
+                      <a:r>
+                        <a:rPr sz="950" b="0">
+                          <a:solidFill>
+                            <a:srgbClr val="1DB954"/>
+                          </a:solidFill>
+                          <a:latin typeface="Consolas"/>
+                        </a:rPr>
+                        <a:t>3</a:t>
+                      </a:r>
+                    </a:p>
+                  </a:txBody>
+                  <a:tcPr>
+                    <a:solidFill>
+                      <a:srgbClr val="0A0A0A"/>
+                    </a:solidFill>
+                  </a:tcPr>
+                </a:tc>
+                <a:tc>
+                  <a:txBody>
+                    <a:bodyPr/>
+                    <a:lstStyle/>
+                    <a:p>
+                      <a:pPr algn="ctr"/>
+                      <a:r>
+                        <a:rPr sz="950" b="0">
+                          <a:solidFill>
+                            <a:srgbClr val="737373"/>
+                          </a:solidFill>
+                          <a:latin typeface="Consolas"/>
+                        </a:rPr>
+                        <a:t>—</a:t>
+                      </a:r>
+                    </a:p>
+                  </a:txBody>
+                  <a:tcPr>
+                    <a:solidFill>
+                      <a:srgbClr val="0A0A0A"/>
+                    </a:solidFill>
+                  </a:tcPr>
+                </a:tc>
+                <a:tc>
+                  <a:txBody>
+                    <a:bodyPr/>
+                    <a:lstStyle/>
+                    <a:p>
+                      <a:pPr algn="ctr"/>
+                      <a:r>
+                        <a:rPr sz="950" b="0">
+                          <a:solidFill>
+                            <a:srgbClr val="FFB000"/>
+                          </a:solidFill>
+                          <a:latin typeface="Consolas"/>
+                        </a:rPr>
+                        <a:t>2</a:t>
+                      </a:r>
+                    </a:p>
+                  </a:txBody>
+                  <a:tcPr>
+                    <a:solidFill>
+                      <a:srgbClr val="0A0A0A"/>
+                    </a:solidFill>
+                  </a:tcPr>
+                </a:tc>
+                <a:tc>
+                  <a:txBody>
+                    <a:bodyPr/>
+                    <a:lstStyle/>
+                    <a:p>
+                      <a:pPr algn="ctr"/>
+                      <a:r>
+                        <a:rPr sz="950" b="0">
+                          <a:solidFill>
+                            <a:srgbClr val="737373"/>
+                          </a:solidFill>
+                          <a:latin typeface="Consolas"/>
+                        </a:rPr>
+                        <a:t>—</a:t>
+                      </a:r>
+                    </a:p>
+                  </a:txBody>
+                  <a:tcPr>
+                    <a:solidFill>
+                      <a:srgbClr val="0A0A0A"/>
+                    </a:solidFill>
+                  </a:tcPr>
+                </a:tc>
+                <a:tc>
+                  <a:txBody>
+                    <a:bodyPr/>
+                    <a:lstStyle/>
+                    <a:p>
+                      <a:pPr algn="ctr"/>
+                      <a:r>
+                        <a:rPr sz="950" b="0">
+                          <a:solidFill>
+                            <a:srgbClr val="FFB000"/>
+                          </a:solidFill>
+                          <a:latin typeface="Consolas"/>
+                        </a:rPr>
+                        <a:t>2</a:t>
+                      </a:r>
+                    </a:p>
+                  </a:txBody>
+                  <a:tcPr>
+                    <a:solidFill>
+                      <a:srgbClr val="0A0A0A"/>
+                    </a:solidFill>
+                  </a:tcPr>
+                </a:tc>
+                <a:tc>
+                  <a:txBody>
+                    <a:bodyPr/>
+                    <a:lstStyle/>
+                    <a:p>
+                      <a:pPr algn="ctr"/>
+                      <a:r>
+                        <a:rPr sz="950" b="0">
+                          <a:solidFill>
+                            <a:srgbClr val="737373"/>
+                          </a:solidFill>
+                          <a:latin typeface="Consolas"/>
+                        </a:rPr>
+                        <a:t>—</a:t>
+                      </a:r>
+                    </a:p>
+                  </a:txBody>
+                  <a:tcPr>
+                    <a:solidFill>
+                      <a:srgbClr val="0A0A0A"/>
+                    </a:solidFill>
+                  </a:tcPr>
+                </a:tc>
+                <a:tc>
+                  <a:txBody>
+                    <a:bodyPr/>
+                    <a:lstStyle/>
+                    <a:p>
+                      <a:pPr algn="ctr"/>
+                      <a:r>
+                        <a:rPr sz="950" b="0">
+                          <a:solidFill>
+                            <a:srgbClr val="737373"/>
+                          </a:solidFill>
+                          <a:latin typeface="Consolas"/>
+                        </a:rPr>
+                        <a:t>—</a:t>
+                      </a:r>
+                    </a:p>
+                  </a:txBody>
+                  <a:tcPr>
+                    <a:solidFill>
+                      <a:srgbClr val="0A0A0A"/>
+                    </a:solidFill>
+                  </a:tcPr>
+                </a:tc>
+                <a:tc>
+                  <a:txBody>
+                    <a:bodyPr/>
+                    <a:lstStyle/>
+                    <a:p>
+                      <a:pPr algn="ctr"/>
+                      <a:r>
+                        <a:rPr sz="950" b="0">
+                          <a:solidFill>
+                            <a:srgbClr val="1DB954"/>
+                          </a:solidFill>
+                          <a:latin typeface="Consolas"/>
+                        </a:rPr>
+                        <a:t>3</a:t>
+                      </a:r>
+                    </a:p>
+                  </a:txBody>
+                  <a:tcPr>
+                    <a:solidFill>
+                      <a:srgbClr val="0A0A0A"/>
+                    </a:solidFill>
+                  </a:tcPr>
+                </a:tc>
+                <a:tc>
+                  <a:txBody>
+                    <a:bodyPr/>
+                    <a:lstStyle/>
+                    <a:p>
+                      <a:pPr algn="ctr"/>
+                      <a:r>
+                        <a:rPr sz="950" b="0">
+                          <a:solidFill>
+                            <a:srgbClr val="1DB954"/>
+                          </a:solidFill>
+                          <a:latin typeface="Consolas"/>
+                        </a:rPr>
+                        <a:t>3</a:t>
+                      </a:r>
+                    </a:p>
+                  </a:txBody>
+                  <a:tcPr>
+                    <a:solidFill>
+                      <a:srgbClr val="0A0A0A"/>
+                    </a:solidFill>
+                  </a:tcPr>
+                </a:tc>
+              </a:tr>
+              <a:tr h="308610">
+                <a:tc>
+                  <a:txBody>
+                    <a:bodyPr/>
+                    <a:lstStyle/>
+                    <a:p>
+                      <a:pPr algn="ctr"/>
+                      <a:r>
+                        <a:rPr sz="950" b="0">
+                          <a:solidFill>
+                            <a:srgbClr val="FFFFFF"/>
+                          </a:solidFill>
+                          <a:latin typeface="Consolas"/>
+                        </a:rPr>
+                        <a:t>CO5</a:t>
+                      </a:r>
+                    </a:p>
+                  </a:txBody>
+                  <a:tcPr>
+                    <a:solidFill>
+                      <a:srgbClr val="0A0A0A"/>
+                    </a:solidFill>
+                  </a:tcPr>
+                </a:tc>
+                <a:tc>
+                  <a:txBody>
+                    <a:bodyPr/>
+                    <a:lstStyle/>
+                    <a:p>
+                      <a:pPr algn="ctr"/>
+                      <a:r>
+                        <a:rPr sz="950" b="0">
+                          <a:solidFill>
+                            <a:srgbClr val="FFB000"/>
+                          </a:solidFill>
+                          <a:latin typeface="Consolas"/>
+                        </a:rPr>
+                        <a:t>2</a:t>
+                      </a:r>
+                    </a:p>
+                  </a:txBody>
+                  <a:tcPr>
+                    <a:solidFill>
+                      <a:srgbClr val="0A0A0A"/>
+                    </a:solidFill>
+                  </a:tcPr>
+                </a:tc>
+                <a:tc>
+                  <a:txBody>
+                    <a:bodyPr/>
+                    <a:lstStyle/>
+                    <a:p>
+                      <a:pPr algn="ctr"/>
+                      <a:r>
+                        <a:rPr sz="950" b="0">
+                          <a:solidFill>
+                            <a:srgbClr val="FFB000"/>
+                          </a:solidFill>
+                          <a:latin typeface="Consolas"/>
+                        </a:rPr>
+                        <a:t>2</a:t>
+                      </a:r>
+                    </a:p>
+                  </a:txBody>
+                  <a:tcPr>
+                    <a:solidFill>
+                      <a:srgbClr val="0A0A0A"/>
+                    </a:solidFill>
+                  </a:tcPr>
+                </a:tc>
+                <a:tc>
+                  <a:txBody>
+                    <a:bodyPr/>
+                    <a:lstStyle/>
+                    <a:p>
+                      <a:pPr algn="ctr"/>
+                      <a:r>
+                        <a:rPr sz="950" b="0">
+                          <a:solidFill>
+                            <a:srgbClr val="737373"/>
+                          </a:solidFill>
+                          <a:latin typeface="Consolas"/>
+                        </a:rPr>
+                        <a:t>—</a:t>
+                      </a:r>
+                    </a:p>
+                  </a:txBody>
+                  <a:tcPr>
+                    <a:solidFill>
+                      <a:srgbClr val="0A0A0A"/>
+                    </a:solidFill>
+                  </a:tcPr>
+                </a:tc>
+                <a:tc>
+                  <a:txBody>
+                    <a:bodyPr/>
+                    <a:lstStyle/>
+                    <a:p>
+                      <a:pPr algn="ctr"/>
+                      <a:r>
+                        <a:rPr sz="950" b="0">
+                          <a:solidFill>
+                            <a:srgbClr val="737373"/>
+                          </a:solidFill>
+                          <a:latin typeface="Consolas"/>
+                        </a:rPr>
+                        <a:t>—</a:t>
+                      </a:r>
+                    </a:p>
+                  </a:txBody>
+                  <a:tcPr>
+                    <a:solidFill>
+                      <a:srgbClr val="0A0A0A"/>
+                    </a:solidFill>
+                  </a:tcPr>
+                </a:tc>
+                <a:tc>
+                  <a:txBody>
+                    <a:bodyPr/>
+                    <a:lstStyle/>
+                    <a:p>
+                      <a:pPr algn="ctr"/>
+                      <a:r>
+                        <a:rPr sz="950" b="0">
+                          <a:solidFill>
+                            <a:srgbClr val="FFB000"/>
+                          </a:solidFill>
+                          <a:latin typeface="Consolas"/>
+                        </a:rPr>
+                        <a:t>2</a:t>
+                      </a:r>
+                    </a:p>
+                  </a:txBody>
+                  <a:tcPr>
+                    <a:solidFill>
+                      <a:srgbClr val="0A0A0A"/>
+                    </a:solidFill>
+                  </a:tcPr>
+                </a:tc>
+                <a:tc>
+                  <a:txBody>
+                    <a:bodyPr/>
+                    <a:lstStyle/>
+                    <a:p>
+                      <a:pPr algn="ctr"/>
+                      <a:r>
+                        <a:rPr sz="950" b="0">
+                          <a:solidFill>
+                            <a:srgbClr val="737373"/>
+                          </a:solidFill>
+                          <a:latin typeface="Consolas"/>
+                        </a:rPr>
+                        <a:t>—</a:t>
+                      </a:r>
+                    </a:p>
+                  </a:txBody>
+                  <a:tcPr>
+                    <a:solidFill>
+                      <a:srgbClr val="0A0A0A"/>
+                    </a:solidFill>
+                  </a:tcPr>
+                </a:tc>
+                <a:tc>
+                  <a:txBody>
+                    <a:bodyPr/>
+                    <a:lstStyle/>
+                    <a:p>
+                      <a:pPr algn="ctr"/>
+                      <a:r>
+                        <a:rPr sz="950" b="0">
+                          <a:solidFill>
+                            <a:srgbClr val="737373"/>
+                          </a:solidFill>
+                          <a:latin typeface="Consolas"/>
+                        </a:rPr>
+                        <a:t>—</a:t>
+                      </a:r>
+                    </a:p>
+                  </a:txBody>
+                  <a:tcPr>
+                    <a:solidFill>
+                      <a:srgbClr val="0A0A0A"/>
+                    </a:solidFill>
+                  </a:tcPr>
+                </a:tc>
+                <a:tc>
+                  <a:txBody>
+                    <a:bodyPr/>
+                    <a:lstStyle/>
+                    <a:p>
+                      <a:pPr algn="ctr"/>
+                      <a:r>
+                        <a:rPr sz="950" b="0">
+                          <a:solidFill>
+                            <a:srgbClr val="737373"/>
+                          </a:solidFill>
+                          <a:latin typeface="Consolas"/>
+                        </a:rPr>
+                        <a:t>—</a:t>
+                      </a:r>
+                    </a:p>
+                  </a:txBody>
+                  <a:tcPr>
+                    <a:solidFill>
+                      <a:srgbClr val="0A0A0A"/>
+                    </a:solidFill>
+                  </a:tcPr>
+                </a:tc>
+                <a:tc>
+                  <a:txBody>
+                    <a:bodyPr/>
+                    <a:lstStyle/>
+                    <a:p>
+                      <a:pPr algn="ctr"/>
+                      <a:r>
+                        <a:rPr sz="950" b="0">
+                          <a:solidFill>
+                            <a:srgbClr val="737373"/>
+                          </a:solidFill>
+                          <a:latin typeface="Consolas"/>
+                        </a:rPr>
+                        <a:t>—</a:t>
+                      </a:r>
+                    </a:p>
+                  </a:txBody>
+                  <a:tcPr>
+                    <a:solidFill>
+                      <a:srgbClr val="0A0A0A"/>
+                    </a:solidFill>
+                  </a:tcPr>
+                </a:tc>
+                <a:tc>
+                  <a:txBody>
+                    <a:bodyPr/>
+                    <a:lstStyle/>
+                    <a:p>
+                      <a:pPr algn="ctr"/>
+                      <a:r>
+                        <a:rPr sz="950" b="0">
+                          <a:solidFill>
+                            <a:srgbClr val="737373"/>
+                          </a:solidFill>
+                          <a:latin typeface="Consolas"/>
+                        </a:rPr>
+                        <a:t>—</a:t>
+                      </a:r>
+                    </a:p>
+                  </a:txBody>
+                  <a:tcPr>
+                    <a:solidFill>
+                      <a:srgbClr val="0A0A0A"/>
+                    </a:solidFill>
+                  </a:tcPr>
+                </a:tc>
+                <a:tc>
+                  <a:txBody>
+                    <a:bodyPr/>
+                    <a:lstStyle/>
+                    <a:p>
+                      <a:pPr algn="ctr"/>
+                      <a:r>
+                        <a:rPr sz="950" b="0">
+                          <a:solidFill>
+                            <a:srgbClr val="737373"/>
+                          </a:solidFill>
+                          <a:latin typeface="Consolas"/>
+                        </a:rPr>
+                        <a:t>—</a:t>
+                      </a:r>
+                    </a:p>
+                  </a:txBody>
+                  <a:tcPr>
+                    <a:solidFill>
+                      <a:srgbClr val="0A0A0A"/>
+                    </a:solidFill>
+                  </a:tcPr>
+                </a:tc>
+                <a:tc>
+                  <a:txBody>
+                    <a:bodyPr/>
+                    <a:lstStyle/>
+                    <a:p>
+                      <a:pPr algn="ctr"/>
+                      <a:r>
+                        <a:rPr sz="950" b="0">
+                          <a:solidFill>
+                            <a:srgbClr val="FFB000"/>
+                          </a:solidFill>
+                          <a:latin typeface="Consolas"/>
+                        </a:rPr>
+                        <a:t>2</a:t>
+                      </a:r>
+                    </a:p>
+                  </a:txBody>
+                  <a:tcPr>
+                    <a:solidFill>
+                      <a:srgbClr val="0A0A0A"/>
+                    </a:solidFill>
+                  </a:tcPr>
+                </a:tc>
+                <a:tc>
+                  <a:txBody>
+                    <a:bodyPr/>
+                    <a:lstStyle/>
+                    <a:p>
+                      <a:pPr algn="ctr"/>
+                      <a:r>
+                        <a:rPr sz="950" b="0">
+                          <a:solidFill>
+                            <a:srgbClr val="FFB000"/>
+                          </a:solidFill>
+                          <a:latin typeface="Consolas"/>
+                        </a:rPr>
+                        <a:t>2</a:t>
+                      </a:r>
+                    </a:p>
+                  </a:txBody>
+                  <a:tcPr>
+                    <a:solidFill>
+                      <a:srgbClr val="0A0A0A"/>
+                    </a:solidFill>
+                  </a:tcPr>
+                </a:tc>
+              </a:tr>
+              <a:tr h="308610">
+                <a:tc>
+                  <a:txBody>
+                    <a:bodyPr/>
+                    <a:lstStyle/>
+                    <a:p>
+                      <a:pPr algn="ctr"/>
+                      <a:r>
+                        <a:rPr sz="950" b="0">
+                          <a:solidFill>
+                            <a:srgbClr val="FFFFFF"/>
+                          </a:solidFill>
+                          <a:latin typeface="Consolas"/>
+                        </a:rPr>
+                        <a:t>CO6</a:t>
+                      </a:r>
+                    </a:p>
+                  </a:txBody>
+                  <a:tcPr>
+                    <a:solidFill>
+                      <a:srgbClr val="0A0A0A"/>
+                    </a:solidFill>
+                  </a:tcPr>
+                </a:tc>
+                <a:tc>
+                  <a:txBody>
+                    <a:bodyPr/>
+                    <a:lstStyle/>
+                    <a:p>
+                      <a:pPr algn="ctr"/>
+                      <a:r>
+                        <a:rPr sz="950" b="0">
+                          <a:solidFill>
+                            <a:srgbClr val="1DB954"/>
+                          </a:solidFill>
+                          <a:latin typeface="Consolas"/>
+                        </a:rPr>
+                        <a:t>3</a:t>
+                      </a:r>
+                    </a:p>
+                  </a:txBody>
+                  <a:tcPr>
+                    <a:solidFill>
+                      <a:srgbClr val="0A0A0A"/>
+                    </a:solidFill>
+                  </a:tcPr>
+                </a:tc>
+                <a:tc>
+                  <a:txBody>
+                    <a:bodyPr/>
+                    <a:lstStyle/>
+                    <a:p>
+                      <a:pPr algn="ctr"/>
+                      <a:r>
+                        <a:rPr sz="950" b="0">
+                          <a:solidFill>
+                            <a:srgbClr val="1DB954"/>
+                          </a:solidFill>
+                          <a:latin typeface="Consolas"/>
+                        </a:rPr>
+                        <a:t>3</a:t>
+                      </a:r>
+                    </a:p>
+                  </a:txBody>
+                  <a:tcPr>
+                    <a:solidFill>
+                      <a:srgbClr val="0A0A0A"/>
+                    </a:solidFill>
+                  </a:tcPr>
+                </a:tc>
+                <a:tc>
+                  <a:txBody>
+                    <a:bodyPr/>
+                    <a:lstStyle/>
+                    <a:p>
+                      <a:pPr algn="ctr"/>
+                      <a:r>
+                        <a:rPr sz="950" b="0">
+                          <a:solidFill>
+                            <a:srgbClr val="1DB954"/>
+                          </a:solidFill>
+                          <a:latin typeface="Consolas"/>
+                        </a:rPr>
+                        <a:t>3</a:t>
+                      </a:r>
+                    </a:p>
+                  </a:txBody>
+                  <a:tcPr>
+                    <a:solidFill>
+                      <a:srgbClr val="0A0A0A"/>
+                    </a:solidFill>
+                  </a:tcPr>
+                </a:tc>
+                <a:tc>
+                  <a:txBody>
+                    <a:bodyPr/>
+                    <a:lstStyle/>
+                    <a:p>
+                      <a:pPr algn="ctr"/>
+                      <a:r>
+                        <a:rPr sz="950" b="0">
+                          <a:solidFill>
+                            <a:srgbClr val="1DB954"/>
+                          </a:solidFill>
+                          <a:latin typeface="Consolas"/>
+                        </a:rPr>
+                        <a:t>3</a:t>
+                      </a:r>
+                    </a:p>
+                  </a:txBody>
+                  <a:tcPr>
+                    <a:solidFill>
+                      <a:srgbClr val="0A0A0A"/>
+                    </a:solidFill>
+                  </a:tcPr>
+                </a:tc>
+                <a:tc>
+                  <a:txBody>
+                    <a:bodyPr/>
+                    <a:lstStyle/>
+                    <a:p>
+                      <a:pPr algn="ctr"/>
+                      <a:r>
+                        <a:rPr sz="950" b="0">
+                          <a:solidFill>
+                            <a:srgbClr val="1DB954"/>
+                          </a:solidFill>
+                          <a:latin typeface="Consolas"/>
+                        </a:rPr>
+                        <a:t>3</a:t>
+                      </a:r>
+                    </a:p>
+                  </a:txBody>
+                  <a:tcPr>
+                    <a:solidFill>
+                      <a:srgbClr val="0A0A0A"/>
+                    </a:solidFill>
+                  </a:tcPr>
+                </a:tc>
+                <a:tc>
+                  <a:txBody>
+                    <a:bodyPr/>
+                    <a:lstStyle/>
+                    <a:p>
+                      <a:pPr algn="ctr"/>
+                      <a:r>
+                        <a:rPr sz="950" b="0">
+                          <a:solidFill>
+                            <a:srgbClr val="FFB000"/>
+                          </a:solidFill>
+                          <a:latin typeface="Consolas"/>
+                        </a:rPr>
+                        <a:t>2</a:t>
+                      </a:r>
+                    </a:p>
+                  </a:txBody>
+                  <a:tcPr>
+                    <a:solidFill>
+                      <a:srgbClr val="0A0A0A"/>
+                    </a:solidFill>
+                  </a:tcPr>
+                </a:tc>
+                <a:tc>
+                  <a:txBody>
+                    <a:bodyPr/>
+                    <a:lstStyle/>
+                    <a:p>
+                      <a:pPr algn="ctr"/>
+                      <a:r>
+                        <a:rPr sz="950" b="0">
+                          <a:solidFill>
+                            <a:srgbClr val="FFB000"/>
+                          </a:solidFill>
+                          <a:latin typeface="Consolas"/>
+                        </a:rPr>
+                        <a:t>2</a:t>
+                      </a:r>
+                    </a:p>
+                  </a:txBody>
+                  <a:tcPr>
+                    <a:solidFill>
+                      <a:srgbClr val="0A0A0A"/>
+                    </a:solidFill>
+                  </a:tcPr>
+                </a:tc>
+                <a:tc>
+                  <a:txBody>
+                    <a:bodyPr/>
+                    <a:lstStyle/>
+                    <a:p>
+                      <a:pPr algn="ctr"/>
+                      <a:r>
+                        <a:rPr sz="950" b="0">
+                          <a:solidFill>
+                            <a:srgbClr val="1DB954"/>
+                          </a:solidFill>
+                          <a:latin typeface="Consolas"/>
+                        </a:rPr>
+                        <a:t>3</a:t>
+                      </a:r>
+                    </a:p>
+                  </a:txBody>
+                  <a:tcPr>
+                    <a:solidFill>
+                      <a:srgbClr val="0A0A0A"/>
+                    </a:solidFill>
+                  </a:tcPr>
+                </a:tc>
+                <a:tc>
+                  <a:txBody>
+                    <a:bodyPr/>
+                    <a:lstStyle/>
+                    <a:p>
+                      <a:pPr algn="ctr"/>
+                      <a:r>
+                        <a:rPr sz="950" b="0">
+                          <a:solidFill>
+                            <a:srgbClr val="1DB954"/>
+                          </a:solidFill>
+                          <a:latin typeface="Consolas"/>
+                        </a:rPr>
+                        <a:t>3</a:t>
+                      </a:r>
+                    </a:p>
+                  </a:txBody>
+                  <a:tcPr>
+                    <a:solidFill>
+                      <a:srgbClr val="0A0A0A"/>
+                    </a:solidFill>
+                  </a:tcPr>
+                </a:tc>
+                <a:tc>
+                  <a:txBody>
+                    <a:bodyPr/>
+                    <a:lstStyle/>
+                    <a:p>
+                      <a:pPr algn="ctr"/>
+                      <a:r>
+                        <a:rPr sz="950" b="0">
+                          <a:solidFill>
+                            <a:srgbClr val="FFB000"/>
+                          </a:solidFill>
+                          <a:latin typeface="Consolas"/>
+                        </a:rPr>
+                        <a:t>2</a:t>
+                      </a:r>
+                    </a:p>
+                  </a:txBody>
+                  <a:tcPr>
+                    <a:solidFill>
+                      <a:srgbClr val="0A0A0A"/>
+                    </a:solidFill>
+                  </a:tcPr>
+                </a:tc>
+                <a:tc>
+                  <a:txBody>
+                    <a:bodyPr/>
+                    <a:lstStyle/>
+                    <a:p>
+                      <a:pPr algn="ctr"/>
+                      <a:r>
+                        <a:rPr sz="950" b="0">
+                          <a:solidFill>
+                            <a:srgbClr val="1DB954"/>
+                          </a:solidFill>
+                          <a:latin typeface="Consolas"/>
+                        </a:rPr>
+                        <a:t>3</a:t>
+                      </a:r>
+                    </a:p>
+                  </a:txBody>
+                  <a:tcPr>
+                    <a:solidFill>
+                      <a:srgbClr val="0A0A0A"/>
+                    </a:solidFill>
+                  </a:tcPr>
+                </a:tc>
+                <a:tc>
+                  <a:txBody>
+                    <a:bodyPr/>
+                    <a:lstStyle/>
+                    <a:p>
+                      <a:pPr algn="ctr"/>
+                      <a:r>
+                        <a:rPr sz="950" b="0">
+                          <a:solidFill>
+                            <a:srgbClr val="1DB954"/>
+                          </a:solidFill>
+                          <a:latin typeface="Consolas"/>
+                        </a:rPr>
+                        <a:t>3</a:t>
+                      </a:r>
+                    </a:p>
+                  </a:txBody>
+                  <a:tcPr>
+                    <a:solidFill>
+                      <a:srgbClr val="0A0A0A"/>
+                    </a:solidFill>
+                  </a:tcPr>
+                </a:tc>
+                <a:tc>
+                  <a:txBody>
+                    <a:bodyPr/>
+                    <a:lstStyle/>
+                    <a:p>
+                      <a:pPr algn="ctr"/>
+                      <a:r>
+                        <a:rPr sz="950" b="0">
+                          <a:solidFill>
+                            <a:srgbClr val="1DB954"/>
+                          </a:solidFill>
+                          <a:latin typeface="Consolas"/>
+                        </a:rPr>
+                        <a:t>3</a:t>
+                      </a:r>
+                    </a:p>
+                  </a:txBody>
+                  <a:tcPr>
+                    <a:solidFill>
+                      <a:srgbClr val="0A0A0A"/>
+                    </a:solidFill>
+                  </a:tcPr>
+                </a:tc>
+              </a:tr>
+              <a:tr h="308610">
+                <a:tc>
+                  <a:txBody>
+                    <a:bodyPr/>
+                    <a:lstStyle/>
+                    <a:p>
+                      <a:pPr algn="ctr"/>
+                      <a:r>
+                        <a:rPr sz="950" b="1">
+                          <a:solidFill>
+                            <a:srgbClr val="1DB954"/>
+                          </a:solidFill>
+                          <a:latin typeface="Consolas"/>
+                        </a:rPr>
+                        <a:t>Avg</a:t>
+                      </a:r>
+                    </a:p>
+                  </a:txBody>
+                  <a:tcPr>
+                    <a:solidFill>
+                      <a:srgbClr val="121212"/>
+                    </a:solidFill>
+                  </a:tcPr>
+                </a:tc>
+                <a:tc>
+                  <a:txBody>
+                    <a:bodyPr/>
+                    <a:lstStyle/>
+                    <a:p>
+                      <a:pPr algn="ctr"/>
+                      <a:r>
+                        <a:rPr sz="950" b="1">
+                          <a:solidFill>
+                            <a:srgbClr val="1DB954"/>
+                          </a:solidFill>
+                          <a:latin typeface="Consolas"/>
+                        </a:rPr>
+                        <a:t>2.83</a:t>
+                      </a:r>
+                    </a:p>
+                  </a:txBody>
+                  <a:tcPr>
+                    <a:solidFill>
+                      <a:srgbClr val="121212"/>
+                    </a:solidFill>
+                  </a:tcPr>
+                </a:tc>
+                <a:tc>
+                  <a:txBody>
+                    <a:bodyPr/>
+                    <a:lstStyle/>
+                    <a:p>
+                      <a:pPr algn="ctr"/>
+                      <a:r>
+                        <a:rPr sz="950" b="1">
+                          <a:solidFill>
+                            <a:srgbClr val="1DB954"/>
+                          </a:solidFill>
+                          <a:latin typeface="Consolas"/>
+                        </a:rPr>
+                        <a:t>2.67</a:t>
+                      </a:r>
+                    </a:p>
+                  </a:txBody>
+                  <a:tcPr>
+                    <a:solidFill>
+                      <a:srgbClr val="121212"/>
+                    </a:solidFill>
+                  </a:tcPr>
+                </a:tc>
+                <a:tc>
+                  <a:txBody>
+                    <a:bodyPr/>
+                    <a:lstStyle/>
+                    <a:p>
+                      <a:pPr algn="ctr"/>
+                      <a:r>
+                        <a:rPr sz="950" b="1">
+                          <a:solidFill>
+                            <a:srgbClr val="1DB954"/>
+                          </a:solidFill>
+                          <a:latin typeface="Consolas"/>
+                        </a:rPr>
+                        <a:t>3.00</a:t>
+                      </a:r>
+                    </a:p>
+                  </a:txBody>
+                  <a:tcPr>
+                    <a:solidFill>
+                      <a:srgbClr val="121212"/>
+                    </a:solidFill>
+                  </a:tcPr>
+                </a:tc>
+                <a:tc>
+                  <a:txBody>
+                    <a:bodyPr/>
+                    <a:lstStyle/>
+                    <a:p>
+                      <a:pPr algn="ctr"/>
+                      <a:r>
+                        <a:rPr sz="950" b="1">
+                          <a:solidFill>
+                            <a:srgbClr val="1DB954"/>
+                          </a:solidFill>
+                          <a:latin typeface="Consolas"/>
+                        </a:rPr>
+                        <a:t>2.60</a:t>
+                      </a:r>
+                    </a:p>
+                  </a:txBody>
+                  <a:tcPr>
+                    <a:solidFill>
+                      <a:srgbClr val="121212"/>
+                    </a:solidFill>
+                  </a:tcPr>
+                </a:tc>
+                <a:tc>
+                  <a:txBody>
+                    <a:bodyPr/>
+                    <a:lstStyle/>
+                    <a:p>
+                      <a:pPr algn="ctr"/>
+                      <a:r>
+                        <a:rPr sz="950" b="1">
+                          <a:solidFill>
+                            <a:srgbClr val="1DB954"/>
+                          </a:solidFill>
+                          <a:latin typeface="Consolas"/>
+                        </a:rPr>
+                        <a:t>2.83</a:t>
+                      </a:r>
+                    </a:p>
+                  </a:txBody>
+                  <a:tcPr>
+                    <a:solidFill>
+                      <a:srgbClr val="121212"/>
+                    </a:solidFill>
+                  </a:tcPr>
+                </a:tc>
+                <a:tc>
+                  <a:txBody>
+                    <a:bodyPr/>
+                    <a:lstStyle/>
+                    <a:p>
+                      <a:pPr algn="ctr"/>
+                      <a:r>
+                        <a:rPr sz="950" b="1">
+                          <a:solidFill>
+                            <a:srgbClr val="1DB954"/>
+                          </a:solidFill>
+                          <a:latin typeface="Consolas"/>
+                        </a:rPr>
+                        <a:t>2.00</a:t>
+                      </a:r>
+                    </a:p>
+                  </a:txBody>
+                  <a:tcPr>
+                    <a:solidFill>
+                      <a:srgbClr val="121212"/>
+                    </a:solidFill>
+                  </a:tcPr>
+                </a:tc>
+                <a:tc>
+                  <a:txBody>
+                    <a:bodyPr/>
+                    <a:lstStyle/>
+                    <a:p>
+                      <a:pPr algn="ctr"/>
+                      <a:r>
+                        <a:rPr sz="950" b="1">
+                          <a:solidFill>
+                            <a:srgbClr val="1DB954"/>
+                          </a:solidFill>
+                          <a:latin typeface="Consolas"/>
+                        </a:rPr>
+                        <a:t>2.00</a:t>
+                      </a:r>
+                    </a:p>
+                  </a:txBody>
+                  <a:tcPr>
+                    <a:solidFill>
+                      <a:srgbClr val="121212"/>
+                    </a:solidFill>
+                  </a:tcPr>
+                </a:tc>
+                <a:tc>
+                  <a:txBody>
+                    <a:bodyPr/>
+                    <a:lstStyle/>
+                    <a:p>
+                      <a:pPr algn="ctr"/>
+                      <a:r>
+                        <a:rPr sz="950" b="1">
+                          <a:solidFill>
+                            <a:srgbClr val="1DB954"/>
+                          </a:solidFill>
+                          <a:latin typeface="Consolas"/>
+                        </a:rPr>
+                        <a:t>2.50</a:t>
+                      </a:r>
+                    </a:p>
+                  </a:txBody>
+                  <a:tcPr>
+                    <a:solidFill>
+                      <a:srgbClr val="121212"/>
+                    </a:solidFill>
+                  </a:tcPr>
+                </a:tc>
+                <a:tc>
+                  <a:txBody>
+                    <a:bodyPr/>
+                    <a:lstStyle/>
+                    <a:p>
+                      <a:pPr algn="ctr"/>
+                      <a:r>
+                        <a:rPr sz="950" b="1">
+                          <a:solidFill>
+                            <a:srgbClr val="1DB954"/>
+                          </a:solidFill>
+                          <a:latin typeface="Consolas"/>
+                        </a:rPr>
+                        <a:t>2.33</a:t>
+                      </a:r>
+                    </a:p>
+                  </a:txBody>
+                  <a:tcPr>
+                    <a:solidFill>
+                      <a:srgbClr val="121212"/>
+                    </a:solidFill>
+                  </a:tcPr>
+                </a:tc>
+                <a:tc>
+                  <a:txBody>
+                    <a:bodyPr/>
+                    <a:lstStyle/>
+                    <a:p>
+                      <a:pPr algn="ctr"/>
+                      <a:r>
+                        <a:rPr sz="950" b="1">
+                          <a:solidFill>
+                            <a:srgbClr val="1DB954"/>
+                          </a:solidFill>
+                          <a:latin typeface="Consolas"/>
+                        </a:rPr>
+                        <a:t>2.00</a:t>
+                      </a:r>
+                    </a:p>
+                  </a:txBody>
+                  <a:tcPr>
+                    <a:solidFill>
+                      <a:srgbClr val="121212"/>
+                    </a:solidFill>
+                  </a:tcPr>
+                </a:tc>
+                <a:tc>
+                  <a:txBody>
+                    <a:bodyPr/>
+                    <a:lstStyle/>
+                    <a:p>
+                      <a:pPr algn="ctr"/>
+                      <a:r>
+                        <a:rPr sz="950" b="1">
+                          <a:solidFill>
+                            <a:srgbClr val="1DB954"/>
+                          </a:solidFill>
+                          <a:latin typeface="Consolas"/>
+                        </a:rPr>
+                        <a:t>3.00</a:t>
+                      </a:r>
+                    </a:p>
+                  </a:txBody>
+                  <a:tcPr>
+                    <a:solidFill>
+                      <a:srgbClr val="121212"/>
+                    </a:solidFill>
+                  </a:tcPr>
+                </a:tc>
+                <a:tc>
+                  <a:txBody>
+                    <a:bodyPr/>
+                    <a:lstStyle/>
+                    <a:p>
+                      <a:pPr algn="ctr"/>
+                      <a:r>
+                        <a:rPr sz="950" b="1">
+                          <a:solidFill>
+                            <a:srgbClr val="1DB954"/>
+                          </a:solidFill>
+                          <a:latin typeface="Consolas"/>
+                        </a:rPr>
+                        <a:t>2.83</a:t>
+                      </a:r>
+                    </a:p>
+                  </a:txBody>
+                  <a:tcPr>
+                    <a:solidFill>
+                      <a:srgbClr val="121212"/>
+                    </a:solidFill>
+                  </a:tcPr>
+                </a:tc>
+                <a:tc>
+                  <a:txBody>
+                    <a:bodyPr/>
+                    <a:lstStyle/>
+                    <a:p>
+                      <a:pPr algn="ctr"/>
+                      <a:r>
+                        <a:rPr sz="950" b="1">
+                          <a:solidFill>
+                            <a:srgbClr val="1DB954"/>
+                          </a:solidFill>
+                          <a:latin typeface="Consolas"/>
+                        </a:rPr>
+                        <a:t>2.67</a:t>
+                      </a:r>
+                    </a:p>
+                  </a:txBody>
+                  <a:tcPr>
+                    <a:solidFill>
+                      <a:srgbClr val="121212"/>
+                    </a:solidFill>
+                  </a:tcPr>
+                </a:tc>
+              </a:tr>
+            </a:tbl>
+          </a:graphicData>
+        </a:graphic>
+      </p:graphicFrame>
+      <p:sp>
+        <p:nvSpPr>
+          <p:cNvPr id="4" name="Rectangle 3"/>
+          <p:cNvSpPr/>
+          <p:nvPr/>
+        </p:nvSpPr>
+        <p:spPr>
+          <a:xfrm>
+            <a:off x="731520" y="3931920"/>
+            <a:ext cx="10698480" cy="2468880"/>
+          </a:xfrm>
+          <a:prstGeom prst="rect">
+            <a:avLst/>
+          </a:prstGeom>
+          <a:solidFill>
+            <a:srgbClr val="121212"/>
+          </a:solidFill>
+          <a:ln w="12700">
+            <a:solidFill>
+              <a:srgbClr val="262626"/>
+            </a:solidFill>
+          </a:ln>
+        </p:spPr>
+        <p:style>
+          <a:lnRef idx="1">
+            <a:schemeClr val="accent1"/>
+          </a:lnRef>
+          <a:fillRef idx="3">
+            <a:schemeClr val="accent1"/>
+          </a:fillRef>
+          <a:effectRef idx="2">
+            <a:schemeClr val="accent1"/>
+          </a:effectRef>
+          <a:fontRef idx="minor">
+            <a:schemeClr val="lt1"/>
+          </a:fontRef>
+        </p:style>
+        <p:txBody>
+          <a:bodyPr rtlCol="0" anchor="ctr"/>
+          <a:lstStyle/>
+          <a:p>
+            <a:pPr algn="ctr"/>
+          </a:p>
+        </p:txBody>
+      </p:sp>
+      <p:sp>
+        <p:nvSpPr>
+          <p:cNvPr id="5" name="TextBox 4"/>
+          <p:cNvSpPr txBox="1"/>
+          <p:nvPr/>
+        </p:nvSpPr>
+        <p:spPr>
+          <a:xfrm>
+            <a:off x="914400" y="4069080"/>
+            <a:ext cx="10332719" cy="320040"/>
+          </a:xfrm>
+          <a:prstGeom prst="rect">
+            <a:avLst/>
+          </a:prstGeom>
+          <a:noFill/>
+        </p:spPr>
+        <p:txBody>
+          <a:bodyPr wrap="square" lIns="0" tIns="0" rIns="0" bIns="0">
+            <a:spAutoFit/>
+          </a:bodyPr>
+          <a:lstStyle/>
+          <a:p>
+            <a:pPr>
+              <a:defRPr sz="1000" b="1">
+                <a:solidFill>
+                  <a:srgbClr val="A1A1AA"/>
+                </a:solidFill>
+                <a:latin typeface="Consolas"/>
+              </a:defRPr>
+            </a:pPr>
+            <a:r>
+              <a:t>EVIDENCE-BASED JUSTIFICATION &amp; ALIGNMENT RATIONALE</a:t>
+            </a:r>
+          </a:p>
+        </p:txBody>
+      </p:sp>
+      <p:sp>
+        <p:nvSpPr>
+          <p:cNvPr id="6" name="TextBox 5"/>
+          <p:cNvSpPr txBox="1"/>
+          <p:nvPr/>
+        </p:nvSpPr>
+        <p:spPr>
+          <a:xfrm>
+            <a:off x="914400" y="4297680"/>
+            <a:ext cx="10332720" cy="1920240"/>
+          </a:xfrm>
+          <a:prstGeom prst="rect">
+            <a:avLst/>
+          </a:prstGeom>
+          <a:noFill/>
+        </p:spPr>
+        <p:txBody>
+          <a:bodyPr wrap="square">
+            <a:spAutoFit/>
+          </a:bodyPr>
+          <a:lstStyle/>
+          <a:p>
+            <a:r>
+              <a:rPr sz="900" b="1">
+                <a:solidFill>
+                  <a:srgbClr val="1DB954"/>
+                </a:solidFill>
+                <a:latin typeface="Consolas"/>
+              </a:rPr>
+              <a:t>• PO1, PO2, PO5 (Avg 2.83, 2.67, 2.83) — Engineering Knowledge, Problem Analysis &amp; Tool Usage: </a:t>
+            </a:r>
+            <a:r>
+              <a:rPr sz="900">
+                <a:solidFill>
+                  <a:srgbClr val="A1A1AA"/>
+                </a:solidFill>
+                <a:latin typeface="Segoe UI"/>
+              </a:rPr>
+              <a:t>Grounds moments, probability distributions, convex optimization (L-BFGS), convolutional geometry, and modern frameworks (TensorFlow, scikit-learn, OpenCV).</a:t>
+            </a:r>
+          </a:p>
+          <a:p>
+            <a:r>
+              <a:rPr sz="900" b="1">
+                <a:solidFill>
+                  <a:srgbClr val="1DB954"/>
+                </a:solidFill>
+                <a:latin typeface="Consolas"/>
+              </a:rPr>
+              <a:t>• PO3, PO4 (Avg 3.00, 2.60) — Solution Design &amp; Complex Problem Investigation: </a:t>
+            </a:r>
+            <a:r>
+              <a:rPr sz="900">
+                <a:solidFill>
+                  <a:srgbClr val="A1A1AA"/>
+                </a:solidFill>
+                <a:latin typeface="Segoe UI"/>
+              </a:rPr>
+              <a:t>Architected DeepConvNet with Global Average Pooling; executed controlled 7-model empirical evaluation on 10,000 isolated test samples under identical conditions.</a:t>
+            </a:r>
+          </a:p>
+          <a:p>
+            <a:r>
+              <a:rPr sz="900" b="1">
+                <a:solidFill>
+                  <a:srgbClr val="1DB954"/>
+                </a:solidFill>
+                <a:latin typeface="Consolas"/>
+              </a:rPr>
+              <a:t>• PO6, PO7 (Avg 2.00, 2.00) — Society, Sustainability &amp; Professional Ethics: </a:t>
+            </a:r>
+            <a:r>
+              <a:rPr sz="900">
+                <a:solidFill>
+                  <a:srgbClr val="A1A1AA"/>
+                </a:solidFill>
+                <a:latin typeface="Segoe UI"/>
+              </a:rPr>
+              <a:t>Evaluated banking/postal automation societal impact, CPU energy efficiency; enforced transparency via Grad-CAM XAI and calibrated OOD rejection.</a:t>
+            </a:r>
+          </a:p>
+          <a:p>
+            <a:r>
+              <a:rPr sz="900" b="1">
+                <a:solidFill>
+                  <a:srgbClr val="1DB954"/>
+                </a:solidFill>
+                <a:latin typeface="Consolas"/>
+              </a:rPr>
+              <a:t>• PO8, PO9, PO10, PO11 (Avg 2.50, 2.33, 2.00, 3.00) — Teamwork, Communication, Mgmt &amp; Lifelong Learning: </a:t>
+            </a:r>
+            <a:r>
+              <a:rPr sz="900">
+                <a:solidFill>
+                  <a:srgbClr val="A1A1AA"/>
+                </a:solidFill>
+                <a:latin typeface="Segoe UI"/>
+              </a:rPr>
+              <a:t>Collaborative division across 3 student roles; comprehensive report and 22-slide deck; self-directed mastery of Keras 3, ECE, and Grad-CAM.</a:t>
             </a:r>
           </a:p>
         </p:txBody>

</xml_diff>